<commit_message>
T42: reliability fallback, validation lines
</commit_message>
<xml_diff>
--- a/docs/deck/clinova.pptx
+++ b/docs/deck/clinova.pptx
@@ -4578,33 +4578,80 @@
         <p:nvPr/>
       </p:nvGrpSpPr>
       <p:grpSpPr/>
-      <p:pic>
-        <p:nvPicPr>
-          <p:cNvPr id="2" name="Picture 1" descr="replay_brier.png"/>
-          <p:cNvPicPr>
-            <a:picLocks noChangeAspect="1"/>
-          </p:cNvPicPr>
-          <p:nvPr/>
-        </p:nvPicPr>
-        <p:blipFill>
-          <a:blip r:embed="rId2"/>
-          <a:stretch>
-            <a:fillRect/>
-          </a:stretch>
-        </p:blipFill>
-        <p:spPr>
-          <a:xfrm>
-            <a:off x="640080" y="2263140"/>
-            <a:ext cx="6949440" cy="3474720"/>
+      <p:sp>
+        <p:nvSpPr>
+          <p:cNvPr id="2" name="Rounded Rectangle 1"/>
+          <p:cNvSpPr/>
+          <p:nvPr/>
+        </p:nvSpPr>
+        <p:spPr>
+          <a:xfrm>
+            <a:off x="640080" y="2240280"/>
+            <a:ext cx="6949440" cy="3566160"/>
+          </a:xfrm>
+          <a:prstGeom prst="roundRect">
+            <a:avLst>
+              <a:gd name="adj" fmla="val 4000"/>
+            </a:avLst>
+          </a:prstGeom>
+          <a:noFill/>
+          <a:ln w="15875">
+            <a:solidFill>
+              <a:srgbClr val="C8492F"/>
+            </a:solidFill>
+          </a:ln>
+        </p:spPr>
+        <p:txBody>
+          <a:bodyPr rtlCol="0" anchor="ctr"/>
+          <a:lstStyle/>
+          <a:p>
+            <a:pPr algn="ctr"/>
+          </a:p>
+        </p:txBody>
+      </p:sp>
+      <p:sp>
+        <p:nvSpPr>
+          <p:cNvPr id="3" name="TextBox 2"/>
+          <p:cNvSpPr txBox="1"/>
+          <p:nvPr/>
+        </p:nvSpPr>
+        <p:spPr>
+          <a:xfrm>
+            <a:off x="914400" y="2240280"/>
+            <a:ext cx="6400800" cy="3566160"/>
           </a:xfrm>
           <a:prstGeom prst="rect">
             <a:avLst/>
           </a:prstGeom>
-        </p:spPr>
-      </p:pic>
-      <p:sp>
-        <p:nvSpPr>
-          <p:cNvPr id="3" name="TextBox 2"/>
+          <a:noFill/>
+        </p:spPr>
+        <p:txBody>
+          <a:bodyPr wrap="square" lIns="0" rIns="0" tIns="0" bIns="0" anchor="ctr"/>
+          <a:lstStyle/>
+          <a:p>
+            <a:pPr algn="ctr">
+              <a:lnSpc>
+                <a:spcPct val="110000"/>
+              </a:lnSpc>
+              <a:spcAft>
+                <a:spcPts val="0"/>
+              </a:spcAft>
+            </a:pPr>
+            <a:r>
+              <a:rPr sz="1800" b="0" i="0">
+                <a:solidFill>
+                  <a:srgbClr val="C8492F"/>
+                </a:solidFill>
+                <a:latin typeface="Arial"/>
+              </a:rPr>
+              <a:t>[TBD: replay chart from docs/replay.json]</a:t>
+            </a:r>
+          </a:p>
+        </p:txBody>
+      </p:sp>
+      <p:sp>
+        <p:nvSpPr>
+          <p:cNvPr id="4" name="TextBox 3"/>
           <p:cNvSpPr txBox="1"/>
           <p:nvPr/>
         </p:nvSpPr>
@@ -4700,7 +4747,7 @@
       </p:sp>
       <p:sp>
         <p:nvSpPr>
-          <p:cNvPr id="4" name="TextBox 3"/>
+          <p:cNvPr id="5" name="TextBox 4"/>
           <p:cNvSpPr txBox="1"/>
           <p:nvPr/>
         </p:nvSpPr>
@@ -4740,7 +4787,7 @@
       </p:sp>
       <p:sp>
         <p:nvSpPr>
-          <p:cNvPr id="5" name="Title"/>
+          <p:cNvPr id="6" name="Title"/>
           <p:cNvSpPr txBox="1"/>
           <p:nvPr/>
         </p:nvSpPr>
@@ -4780,7 +4827,7 @@
       </p:sp>
       <p:sp>
         <p:nvSpPr>
-          <p:cNvPr id="6" name="TextBox 5"/>
+          <p:cNvPr id="7" name="TextBox 6"/>
           <p:cNvSpPr txBox="1"/>
           <p:nvPr/>
         </p:nvSpPr>
@@ -4820,7 +4867,7 @@
       </p:sp>
       <p:sp>
         <p:nvSpPr>
-          <p:cNvPr id="7" name="TextBox 6"/>
+          <p:cNvPr id="8" name="TextBox 7"/>
           <p:cNvSpPr txBox="1"/>
           <p:nvPr/>
         </p:nvSpPr>
@@ -4860,7 +4907,7 @@
       </p:sp>
       <p:sp>
         <p:nvSpPr>
-          <p:cNvPr id="8" name="Rounded Rectangle 7"/>
+          <p:cNvPr id="9" name="Rounded Rectangle 8"/>
           <p:cNvSpPr/>
           <p:nvPr/>
         </p:nvSpPr>
@@ -10978,64 +11025,158 @@
         <p:nvPr/>
       </p:nvGrpSpPr>
       <p:grpSpPr/>
-      <p:pic>
-        <p:nvPicPr>
-          <p:cNvPr id="2" name="Picture 1" descr="auc_vs_baseline.png"/>
-          <p:cNvPicPr>
-            <a:picLocks noChangeAspect="1"/>
-          </p:cNvPicPr>
-          <p:nvPr/>
-        </p:nvPicPr>
-        <p:blipFill>
-          <a:blip r:embed="rId2"/>
-          <a:stretch>
-            <a:fillRect/>
-          </a:stretch>
-        </p:blipFill>
-        <p:spPr>
-          <a:xfrm>
-            <a:off x="1144792" y="2148840"/>
-            <a:ext cx="4934174" cy="2926080"/>
+      <p:sp>
+        <p:nvSpPr>
+          <p:cNvPr id="2" name="Rounded Rectangle 1"/>
+          <p:cNvSpPr/>
+          <p:nvPr/>
+        </p:nvSpPr>
+        <p:spPr>
+          <a:xfrm>
+            <a:off x="640080" y="2240280"/>
+            <a:ext cx="5943600" cy="3108960"/>
+          </a:xfrm>
+          <a:prstGeom prst="roundRect">
+            <a:avLst>
+              <a:gd name="adj" fmla="val 4000"/>
+            </a:avLst>
+          </a:prstGeom>
+          <a:noFill/>
+          <a:ln w="15875">
+            <a:solidFill>
+              <a:srgbClr val="C8492F"/>
+            </a:solidFill>
+          </a:ln>
+        </p:spPr>
+        <p:txBody>
+          <a:bodyPr rtlCol="0" anchor="ctr"/>
+          <a:lstStyle/>
+          <a:p>
+            <a:pPr algn="ctr"/>
+          </a:p>
+        </p:txBody>
+      </p:sp>
+      <p:sp>
+        <p:nvSpPr>
+          <p:cNvPr id="3" name="TextBox 2"/>
+          <p:cNvSpPr txBox="1"/>
+          <p:nvPr/>
+        </p:nvSpPr>
+        <p:spPr>
+          <a:xfrm>
+            <a:off x="914400" y="2240280"/>
+            <a:ext cx="5394960" cy="3108960"/>
           </a:xfrm>
           <a:prstGeom prst="rect">
             <a:avLst/>
           </a:prstGeom>
-        </p:spPr>
-      </p:pic>
-      <p:pic>
-        <p:nvPicPr>
-          <p:cNvPr id="3" name="Picture 2" descr="hit_rate.png"/>
-          <p:cNvPicPr>
-            <a:picLocks noChangeAspect="1"/>
-          </p:cNvPicPr>
-          <p:nvPr/>
-        </p:nvPicPr>
-        <p:blipFill>
-          <a:blip r:embed="rId3"/>
-          <a:stretch>
-            <a:fillRect/>
-          </a:stretch>
-        </p:blipFill>
-        <p:spPr>
-          <a:xfrm>
-            <a:off x="6955582" y="2148840"/>
-            <a:ext cx="4452730" cy="2926080"/>
+          <a:noFill/>
+        </p:spPr>
+        <p:txBody>
+          <a:bodyPr wrap="square" lIns="0" rIns="0" tIns="0" bIns="0" anchor="ctr"/>
+          <a:lstStyle/>
+          <a:p>
+            <a:pPr algn="ctr">
+              <a:lnSpc>
+                <a:spcPct val="110000"/>
+              </a:lnSpc>
+              <a:spcAft>
+                <a:spcPts val="0"/>
+              </a:spcAft>
+            </a:pPr>
+            <a:r>
+              <a:rPr sz="1800" b="0" i="0">
+                <a:solidFill>
+                  <a:srgbClr val="C8492F"/>
+                </a:solidFill>
+                <a:latin typeface="Arial"/>
+              </a:rPr>
+              <a:t>[TBD: AUC chart from docs/metrics.json]</a:t>
+            </a:r>
+          </a:p>
+        </p:txBody>
+      </p:sp>
+      <p:sp>
+        <p:nvSpPr>
+          <p:cNvPr id="4" name="Rounded Rectangle 3"/>
+          <p:cNvSpPr/>
+          <p:nvPr/>
+        </p:nvSpPr>
+        <p:spPr>
+          <a:xfrm>
+            <a:off x="6812280" y="2240280"/>
+            <a:ext cx="4739335" cy="3108960"/>
+          </a:xfrm>
+          <a:prstGeom prst="roundRect">
+            <a:avLst>
+              <a:gd name="adj" fmla="val 4000"/>
+            </a:avLst>
+          </a:prstGeom>
+          <a:noFill/>
+          <a:ln w="15875">
+            <a:solidFill>
+              <a:srgbClr val="C8492F"/>
+            </a:solidFill>
+          </a:ln>
+        </p:spPr>
+        <p:txBody>
+          <a:bodyPr rtlCol="0" anchor="ctr"/>
+          <a:lstStyle/>
+          <a:p>
+            <a:pPr algn="ctr"/>
+          </a:p>
+        </p:txBody>
+      </p:sp>
+      <p:sp>
+        <p:nvSpPr>
+          <p:cNvPr id="5" name="TextBox 4"/>
+          <p:cNvSpPr txBox="1"/>
+          <p:nvPr/>
+        </p:nvSpPr>
+        <p:spPr>
+          <a:xfrm>
+            <a:off x="7086600" y="2240280"/>
+            <a:ext cx="4190695" cy="3108960"/>
           </a:xfrm>
           <a:prstGeom prst="rect">
             <a:avLst/>
           </a:prstGeom>
-        </p:spPr>
-      </p:pic>
-      <p:sp>
-        <p:nvSpPr>
-          <p:cNvPr id="4" name="TextBox 3"/>
+          <a:noFill/>
+        </p:spPr>
+        <p:txBody>
+          <a:bodyPr wrap="square" lIns="0" rIns="0" tIns="0" bIns="0" anchor="ctr"/>
+          <a:lstStyle/>
+          <a:p>
+            <a:pPr algn="ctr">
+              <a:lnSpc>
+                <a:spcPct val="110000"/>
+              </a:lnSpc>
+              <a:spcAft>
+                <a:spcPts val="0"/>
+              </a:spcAft>
+            </a:pPr>
+            <a:r>
+              <a:rPr sz="1800" b="0" i="0">
+                <a:solidFill>
+                  <a:srgbClr val="C8492F"/>
+                </a:solidFill>
+                <a:latin typeface="Arial"/>
+              </a:rPr>
+              <a:t>[TBD: hit-rate chart from docs/metrics.json]</a:t>
+            </a:r>
+          </a:p>
+        </p:txBody>
+      </p:sp>
+      <p:sp>
+        <p:nvSpPr>
+          <p:cNvPr id="6" name="TextBox 5"/>
           <p:cNvSpPr txBox="1"/>
           <p:nvPr/>
         </p:nvSpPr>
         <p:spPr>
           <a:xfrm>
-            <a:off x="640080" y="5257800"/>
-            <a:ext cx="10911535" cy="1463040"/>
+            <a:off x="640080" y="5029200"/>
+            <a:ext cx="10911535" cy="1417320"/>
           </a:xfrm>
           <a:prstGeom prst="rect">
             <a:avLst/>
@@ -11124,7 +11265,7 @@
       </p:sp>
       <p:sp>
         <p:nvSpPr>
-          <p:cNvPr id="5" name="TextBox 4"/>
+          <p:cNvPr id="7" name="TextBox 6"/>
           <p:cNvSpPr txBox="1"/>
           <p:nvPr/>
         </p:nvSpPr>
@@ -11164,7 +11305,7 @@
       </p:sp>
       <p:sp>
         <p:nvSpPr>
-          <p:cNvPr id="6" name="Title"/>
+          <p:cNvPr id="8" name="Title"/>
           <p:cNvSpPr txBox="1"/>
           <p:nvPr/>
         </p:nvSpPr>
@@ -11204,7 +11345,7 @@
       </p:sp>
       <p:sp>
         <p:nvSpPr>
-          <p:cNvPr id="7" name="TextBox 6"/>
+          <p:cNvPr id="9" name="TextBox 8"/>
           <p:cNvSpPr txBox="1"/>
           <p:nvPr/>
         </p:nvSpPr>
@@ -11244,7 +11385,7 @@
       </p:sp>
       <p:sp>
         <p:nvSpPr>
-          <p:cNvPr id="8" name="TextBox 7"/>
+          <p:cNvPr id="10" name="TextBox 9"/>
           <p:cNvSpPr txBox="1"/>
           <p:nvPr/>
         </p:nvSpPr>
@@ -11284,7 +11425,7 @@
       </p:sp>
       <p:sp>
         <p:nvSpPr>
-          <p:cNvPr id="9" name="Rounded Rectangle 8"/>
+          <p:cNvPr id="11" name="Rounded Rectangle 10"/>
           <p:cNvSpPr/>
           <p:nvPr/>
         </p:nvSpPr>

</xml_diff>

<commit_message>
T42: fill gate 2 numbers (validation, replay, demo flags and fixes)
</commit_message>
<xml_diff>
--- a/docs/deck/clinova.pptx
+++ b/docs/deck/clinova.pptx
@@ -583,7 +583,7 @@
           <a:lstStyle/>
           <a:p>
             <a:r>
-              <a:t>The replay freezes a model on [TBD: freeze date], then steps month by month from [TBD: first month] to [TBD: last month]: it scores trials whose outcome arrives within ? months, then adds that month's outcomes and retrains. The frozen arm never retrains. Pooled over [TBD: replay.json windows] scored windows the retrained Brier is [TBD: replay.json retrained Brier] against [TBD: replay.json frozen Brier] frozen. Windows overlap, so this is descriptive, not a significance test. Source: docs/replay.json.</a:t>
+              <a:t>The replay freezes a model on 2019-12-31, then steps month by month from 2020-01 to 2023-12: it scores trials whose outcome arrives within 6 months, then adds that month's outcomes and retrains. The frozen arm never retrains. Pooled over 1,736 scored windows the retrained Brier is 0.078 against 0.077 frozen. Windows overlap, so this is descriptive, not a significance test. Source: docs/replay.json.</a:t>
             </a:r>
           </a:p>
         </p:txBody>
@@ -653,7 +653,7 @@
           <a:lstStyle/>
           <a:p>
             <a:r>
-              <a:t>Four limits. Registry edits are a public proxy for amendments, not the same thing. Stop reasons are free text, and some terminations are business decisions. Personas are general-population records given clinical traits from published distributions, labelled as assumptions. Predictions are correlational. On responsible use: no real patient data is used; Clinova advises the protocol author, logs every accept and reject, and never approves a protocol. Source: docs/ARCHITECTURE.md section 10 and the caveats in docs/metrics.json notes.</a:t>
+              <a:t>Four limits. Accrual AUC is above chance, but its paired gain over a logistic baseline includes zero. Version histories are not loaded yet, so hit rate and amendment risk are unmeasured. Clinical traits come from published distributions; too few simulated trials to test their benefit. They rank protocols against similar trials; they do not show that a rule caused a failure. Clinova uses no real patient data, advises the protocol author, logs every accept and reject, and never approves a protocol. Sources: docs/gate2_report.md, docs/metrics.json notes.</a:t>
             </a:r>
           </a:p>
         </p:txBody>
@@ -1003,7 +1003,7 @@
           <a:lstStyle/>
           <a:p>
             <a:r>
-              <a:t>This is a real trial, NCT03232892, from the test split, terminated on 2019-09-11 with the stop reason "Low Accrual" (docs/demo_trial.md). We load only its first registered protocol. 21.4% of 1,000 virtual patients pass every criterion, and ECOG &lt;= 1 removes 35% on its own (funnel: docs/gate1_e2e.json (seed 1)). Later the sponsor removed prior platinum, cardiac condition. Did our top 3 flags include the widened rule? [TBD: demo flags (docs/deck/data/demo.json)]. Flags: docs/deck/data/demo.json. Version histories confirm the change only from first versus current text.</a:t>
+              <a:t>NCT03232892 is a test-split trial terminated on 2019-09-11, stop reason "Low Accrual" (docs/demo_trial.md). Clinova saw only its first registered protocol. Flag #1: prior platinum therapy (I3), the rule the sponsor later removed; alone it excludes 63%. The model predicts no risk change for any flag, so this is an exclusion-share ranking. Honest miss: predicted accrual-failure risk 7% (range 6% to 12%), the 50th percentile of test trials: the model misses this trial. The removal is inferred from first versus current text, not a dated version history. Source: docs/demo_results/NCT03232892.json.</a:t>
             </a:r>
           </a:p>
         </p:txBody>
@@ -1073,7 +1073,7 @@
           <a:lstStyle/>
           <a:p>
             <a:r>
-              <a:t>This is the results screen of the running app. Left, the funnel: virtual patients screened, excluded by each criterion, enrolled and completing, with the biggest exclusion highlighted. Middle, risk: calibrated probabilities of accrual failure, enrollment shortfall and amendment, each with a range, a confidence badge and the top drivers in plain words. Right, three fixes. Everything else sits behind tabs: validation, replay, community pulse and the audit log. Screenshot: docs/screens/03-results.png.</a:t>
+              <a:t>This is the results screen of the running app. Left, the funnel: virtual patients screened, excluded by each criterion, enrolled and completing, with the biggest exclusion highlighted. Middle, risk: probabilities of accrual failure and enrollment shortfall, each with a range, a confidence badge and the top drivers in plain words. Right, three fixes the author can accept or reject. Everything else sits behind tabs: validation, replay, community pulse and the audit log. Screenshot: docs/screens/03-results.png.</a:t>
             </a:r>
           </a:p>
         </p:txBody>
@@ -1143,7 +1143,7 @@
           <a:lstStyle/>
           <a:p>
             <a:r>
-              <a:t>For NCT03232892 the optimizer, Optuna NSGA-II over at most three edits, returns three representative fixes. [TBD: fix numbers]. Ranges span five cohort seeds. The dollar figure is the expected value of avoided amendments: the drop in amendment probability times the phase's median amendment cost. Accepting a fix logs the decision and re-runs the screen in seconds. Numbers: docs/deck/data/demo.json.</a:t>
+              <a:t>For NCT03232892 the optimizer, Optuna NSGA-II over at most three edits, returns three representative fixes. Fastest enrollment: enrollment speed +101%, dropout +4.4 pts. Fewest dropouts: enrollment speed +53%, dropout -2.0 pts. Balanced: enrollment speed +95%, dropout +3.6 pts. Ranges span 5 cohort seeds. We show no dollars: the amendment model has no positive labels yet. 1 of the three include a rule the sponsor later removed. Source: docs/demo_results/NCT03232892_optimize.json.</a:t>
             </a:r>
           </a:p>
         </p:txBody>
@@ -1283,7 +1283,7 @@
           <a:lstStyle/>
           <a:p>
             <a:r>
-              <a:t>Time split: train on trials that started before 2018 ([TBD: metrics.json n_train] labelled), test on 2018 or later ([TBD: metrics.json n_test]). Accrual-failure AUC is [TBD: metrics.json accrual_fail AUC], 95% CI , against [TBD: metrics.json accrual_fail AUC baseline] for a ten-feature logistic baseline; Brier [TBD: Brier] vs [TBD: baseline Brier]. Shortfall AUC is [TBD: metrics.json shortfall AUC] vs [TBD: metrics.json shortfall AUC baseline]. Hit rate: [TBD: metrics.json hit_rate] (random [TBD: metrics.json hit_rate random], largest exclusion [TBD: metrics.json hit_rate marginal]). Simulation ablation: [TBD: metrics.json ablation diff]. Model [TBD: model_version]; every number is from docs/metrics.json.</a:t>
+              <a:t>Train: trials starting before 2018 (1,424); test: 2018 or later (360). Accrual-failure AUC is 0.70 against 0.66 for a logistic baseline. The paired gain is +0.04, interval −0.04 to +0.12; over sponsor type alone +0.03. So it ranks failures above chance but is not shown to beat simple baselines. Shortfall AUC is 0.60 vs 0.60, so it is not validated. Hit rate not computable: no test trial has an amendment label yet. Simulation ablation not computable: too few simulated trials. Model v1.0: docs/metrics.json, docs/metrics_detail.json.</a:t>
             </a:r>
           </a:p>
         </p:txBody>
@@ -4578,37 +4578,30 @@
         <p:nvPr/>
       </p:nvGrpSpPr>
       <p:grpSpPr/>
-      <p:sp>
-        <p:nvSpPr>
-          <p:cNvPr id="2" name="Rounded Rectangle 1"/>
-          <p:cNvSpPr/>
-          <p:nvPr/>
-        </p:nvSpPr>
-        <p:spPr>
-          <a:xfrm>
-            <a:off x="640080" y="2240280"/>
-            <a:ext cx="6949440" cy="3566160"/>
-          </a:xfrm>
-          <a:prstGeom prst="roundRect">
-            <a:avLst>
-              <a:gd name="adj" fmla="val 4000"/>
-            </a:avLst>
-          </a:prstGeom>
-          <a:noFill/>
-          <a:ln w="15875">
-            <a:solidFill>
-              <a:srgbClr val="C8492F"/>
-            </a:solidFill>
-          </a:ln>
-        </p:spPr>
-        <p:txBody>
-          <a:bodyPr rtlCol="0" anchor="ctr"/>
-          <a:lstStyle/>
-          <a:p>
-            <a:pPr algn="ctr"/>
-          </a:p>
-        </p:txBody>
-      </p:sp>
+      <p:pic>
+        <p:nvPicPr>
+          <p:cNvPr id="2" name="Picture 1" descr="replay_brier.png"/>
+          <p:cNvPicPr>
+            <a:picLocks noChangeAspect="1"/>
+          </p:cNvPicPr>
+          <p:nvPr/>
+        </p:nvPicPr>
+        <p:blipFill>
+          <a:blip r:embed="rId2"/>
+          <a:stretch>
+            <a:fillRect/>
+          </a:stretch>
+        </p:blipFill>
+        <p:spPr>
+          <a:xfrm>
+            <a:off x="640080" y="2263140"/>
+            <a:ext cx="6949440" cy="3474720"/>
+          </a:xfrm>
+          <a:prstGeom prst="rect">
+            <a:avLst/>
+          </a:prstGeom>
+        </p:spPr>
+      </p:pic>
       <p:sp>
         <p:nvSpPr>
           <p:cNvPr id="3" name="TextBox 2"/>
@@ -4617,48 +4610,8 @@
         </p:nvSpPr>
         <p:spPr>
           <a:xfrm>
-            <a:off x="914400" y="2240280"/>
-            <a:ext cx="6400800" cy="3566160"/>
-          </a:xfrm>
-          <a:prstGeom prst="rect">
-            <a:avLst/>
-          </a:prstGeom>
-          <a:noFill/>
-        </p:spPr>
-        <p:txBody>
-          <a:bodyPr wrap="square" lIns="0" rIns="0" tIns="0" bIns="0" anchor="ctr"/>
-          <a:lstStyle/>
-          <a:p>
-            <a:pPr algn="ctr">
-              <a:lnSpc>
-                <a:spcPct val="110000"/>
-              </a:lnSpc>
-              <a:spcAft>
-                <a:spcPts val="0"/>
-              </a:spcAft>
-            </a:pPr>
-            <a:r>
-              <a:rPr sz="1800" b="0" i="0">
-                <a:solidFill>
-                  <a:srgbClr val="C8492F"/>
-                </a:solidFill>
-                <a:latin typeface="Arial"/>
-              </a:rPr>
-              <a:t>[TBD: replay chart from docs/replay.json]</a:t>
-            </a:r>
-          </a:p>
-        </p:txBody>
-      </p:sp>
-      <p:sp>
-        <p:nvSpPr>
-          <p:cNvPr id="4" name="TextBox 3"/>
-          <p:cNvSpPr txBox="1"/>
-          <p:nvPr/>
-        </p:nvSpPr>
-        <p:spPr>
-          <a:xfrm>
             <a:off x="8000999" y="2377440"/>
-            <a:ext cx="3550615" cy="2194560"/>
+            <a:ext cx="3550615" cy="3474720"/>
           </a:xfrm>
           <a:prstGeom prst="rect">
             <a:avLst/>
@@ -4690,7 +4643,7 @@
                 </a:solidFill>
                 <a:latin typeface="Arial"/>
               </a:rPr>
-              <a:t>Replay [TBD: first month] to [TBD: last month]: score each month, then learn its outcomes</a:t>
+              <a:t>Replay 2020-01 to 2023-12: score each month, then learn its outcomes</a:t>
             </a:r>
           </a:p>
           <a:p>
@@ -4715,7 +4668,7 @@
                 </a:solidFill>
                 <a:latin typeface="Arial"/>
               </a:rPr>
-              <a:t>Pooled Brier over [TBD: replay.json windows] scored windows: retrained [TBD: replay.json retrained Brier], frozen [TBD: replay.json frozen Brier]</a:t>
+              <a:t>Pooled Brier over 1,736 overlapping windows: retrained 0.078, frozen 0.077</a:t>
             </a:r>
           </a:p>
           <a:p>
@@ -4747,7 +4700,7 @@
       </p:sp>
       <p:sp>
         <p:nvSpPr>
-          <p:cNvPr id="5" name="TextBox 4"/>
+          <p:cNvPr id="4" name="TextBox 3"/>
           <p:cNvSpPr txBox="1"/>
           <p:nvPr/>
         </p:nvSpPr>
@@ -4787,7 +4740,7 @@
       </p:sp>
       <p:sp>
         <p:nvSpPr>
-          <p:cNvPr id="6" name="Title"/>
+          <p:cNvPr id="5" name="Title"/>
           <p:cNvSpPr txBox="1"/>
           <p:nvPr/>
         </p:nvSpPr>
@@ -4820,7 +4773,47 @@
                 </a:solidFill>
                 <a:latin typeface="Arial"/>
               </a:rPr>
-              <a:t>The learning loop grades every prediction; retrained Brier [TBD: replay.json retrained Brier] vs frozen [TBD: replay.json frozen Brier]</a:t>
+              <a:t>In a 2020–2023 replay, monthly retraining did not beat the frozen model (Brier 0.078 vs 0.077)</a:t>
+            </a:r>
+          </a:p>
+        </p:txBody>
+      </p:sp>
+      <p:sp>
+        <p:nvSpPr>
+          <p:cNvPr id="6" name="TextBox 5"/>
+          <p:cNvSpPr txBox="1"/>
+          <p:nvPr/>
+        </p:nvSpPr>
+        <p:spPr>
+          <a:xfrm>
+            <a:off x="10637215" y="6400800"/>
+            <a:ext cx="914400" cy="274320"/>
+          </a:xfrm>
+          <a:prstGeom prst="rect">
+            <a:avLst/>
+          </a:prstGeom>
+          <a:noFill/>
+        </p:spPr>
+        <p:txBody>
+          <a:bodyPr wrap="square" lIns="0" rIns="0" tIns="0" bIns="0" anchor="t"/>
+          <a:lstStyle/>
+          <a:p>
+            <a:pPr algn="r">
+              <a:lnSpc>
+                <a:spcPct val="110000"/>
+              </a:lnSpc>
+              <a:spcAft>
+                <a:spcPts val="0"/>
+              </a:spcAft>
+            </a:pPr>
+            <a:r>
+              <a:rPr sz="1100" b="0" i="0">
+                <a:solidFill>
+                  <a:srgbClr val="A9B4B8"/>
+                </a:solidFill>
+                <a:latin typeface="Arial"/>
+              </a:rPr>
+              <a:t>10 / 12</a:t>
             </a:r>
           </a:p>
         </p:txBody>
@@ -4833,46 +4826,6 @@
         </p:nvSpPr>
         <p:spPr>
           <a:xfrm>
-            <a:off x="10637215" y="6400800"/>
-            <a:ext cx="914400" cy="274320"/>
-          </a:xfrm>
-          <a:prstGeom prst="rect">
-            <a:avLst/>
-          </a:prstGeom>
-          <a:noFill/>
-        </p:spPr>
-        <p:txBody>
-          <a:bodyPr wrap="square" lIns="0" rIns="0" tIns="0" bIns="0" anchor="t"/>
-          <a:lstStyle/>
-          <a:p>
-            <a:pPr algn="r">
-              <a:lnSpc>
-                <a:spcPct val="110000"/>
-              </a:lnSpc>
-              <a:spcAft>
-                <a:spcPts val="0"/>
-              </a:spcAft>
-            </a:pPr>
-            <a:r>
-              <a:rPr sz="1100" b="0" i="0">
-                <a:solidFill>
-                  <a:srgbClr val="A9B4B8"/>
-                </a:solidFill>
-                <a:latin typeface="Arial"/>
-              </a:rPr>
-              <a:t>10 / 12</a:t>
-            </a:r>
-          </a:p>
-        </p:txBody>
-      </p:sp>
-      <p:sp>
-        <p:nvSpPr>
-          <p:cNvPr id="8" name="TextBox 7"/>
-          <p:cNvSpPr txBox="1"/>
-          <p:nvPr/>
-        </p:nvSpPr>
-        <p:spPr>
-          <a:xfrm>
             <a:off x="640080" y="6400800"/>
             <a:ext cx="8686800" cy="274320"/>
           </a:xfrm>
@@ -4901,46 +4854,6 @@
                 <a:latin typeface="Arial"/>
               </a:rPr>
               <a:t>Sources: docs/replay.json</a:t>
-            </a:r>
-          </a:p>
-        </p:txBody>
-      </p:sp>
-      <p:sp>
-        <p:nvSpPr>
-          <p:cNvPr id="9" name="Rounded Rectangle 8"/>
-          <p:cNvSpPr/>
-          <p:nvPr/>
-        </p:nvSpPr>
-        <p:spPr>
-          <a:xfrm>
-            <a:off x="8534095" y="384048"/>
-            <a:ext cx="3017520" cy="384048"/>
-          </a:xfrm>
-          <a:prstGeom prst="roundRect">
-            <a:avLst>
-              <a:gd name="adj" fmla="val 30000"/>
-            </a:avLst>
-          </a:prstGeom>
-          <a:solidFill>
-            <a:srgbClr val="C8492F"/>
-          </a:solidFill>
-          <a:ln>
-            <a:noFill/>
-          </a:ln>
-        </p:spPr>
-        <p:txBody>
-          <a:bodyPr rtlCol="0" anchor="ctr" tIns="0" bIns="0"/>
-          <a:lstStyle/>
-          <a:p>
-            <a:pPr algn="ctr"/>
-            <a:r>
-              <a:rPr sz="1200" b="1">
-                <a:solidFill>
-                  <a:srgbClr val="FFFFFF"/>
-                </a:solidFill>
-                <a:latin typeface="Arial"/>
-              </a:rPr>
-              <a:t>DRAFT: placeholder numbers</a:t>
             </a:r>
           </a:p>
         </p:txBody>
@@ -5037,7 +4950,7 @@
                 </a:solidFill>
                 <a:latin typeface="Arial"/>
               </a:rPr>
-              <a:t>Registry edits are a proxy</a:t>
+              <a:t>Not shown to beat simple baselines</a:t>
             </a:r>
           </a:p>
         </p:txBody>
@@ -5077,7 +4990,7 @@
                 </a:solidFill>
                 <a:latin typeface="Arial"/>
               </a:rPr>
-              <a:t>A widened rule on ClinicalTrials.gov is public evidence of an amendment, not the same thing</a:t>
+              <a:t>Accrual AUC is above chance, but its paired gain over a logistic baseline includes zero</a:t>
             </a:r>
           </a:p>
         </p:txBody>
@@ -5148,7 +5061,7 @@
                 </a:solidFill>
                 <a:latin typeface="Arial"/>
               </a:rPr>
-              <a:t>Stop reasons are free text</a:t>
+              <a:t>Amendment labels are missing</a:t>
             </a:r>
           </a:p>
         </p:txBody>
@@ -5188,7 +5101,7 @@
                 </a:solidFill>
                 <a:latin typeface="Arial"/>
               </a:rPr>
-              <a:t>Some terminations are business decisions; labels were spot-checked by a second model</a:t>
+              <a:t>Version histories are not loaded yet, so hit rate and amendment risk are unmeasured</a:t>
             </a:r>
           </a:p>
         </p:txBody>
@@ -5299,7 +5212,7 @@
                 </a:solidFill>
                 <a:latin typeface="Arial"/>
               </a:rPr>
-              <a:t>General-population records with clinical traits from published distributions, labelled as assumptions</a:t>
+              <a:t>Clinical traits come from published distributions; too few simulated trials to test their benefit</a:t>
             </a:r>
           </a:p>
         </p:txBody>
@@ -5370,7 +5283,7 @@
                 </a:solidFill>
                 <a:latin typeface="Arial"/>
               </a:rPr>
-              <a:t>Predictions are correlational</a:t>
+              <a:t>Scores are correlational</a:t>
             </a:r>
           </a:p>
         </p:txBody>
@@ -5410,7 +5323,7 @@
                 </a:solidFill>
                 <a:latin typeface="Arial"/>
               </a:rPr>
-              <a:t>Risk scores rank protocols; they do not prove that a rule caused a failure</a:t>
+              <a:t>They rank protocols against similar trials; they do not show that a rule caused a failure</a:t>
             </a:r>
           </a:p>
         </p:txBody>
@@ -5641,7 +5554,7 @@
                 </a:solidFill>
                 <a:latin typeface="Arial"/>
               </a:rPr>
-              <a:t>Sources: docs/ARCHITECTURE.md, docs/metrics.json</a:t>
+              <a:t>Sources: docs/gate2_report.md, docs/metrics.json</a:t>
             </a:r>
           </a:p>
         </p:txBody>
@@ -8788,7 +8701,7 @@
       <p:grpSpPr/>
       <p:pic>
         <p:nvPicPr>
-          <p:cNvPr id="2" name="Picture 1" descr="demo_exclusions.png"/>
+          <p:cNvPr id="2" name="Picture 1" descr="demo_flags.png"/>
           <p:cNvPicPr>
             <a:picLocks noChangeAspect="1"/>
           </p:cNvPicPr>
@@ -8802,8 +8715,8 @@
         </p:blipFill>
         <p:spPr>
           <a:xfrm>
-            <a:off x="640080" y="2266749"/>
-            <a:ext cx="5852159" cy="3696101"/>
+            <a:off x="640080" y="2567538"/>
+            <a:ext cx="5760719" cy="2728762"/>
           </a:xfrm>
           <a:prstGeom prst="rect">
             <a:avLst/>
@@ -8818,8 +8731,8 @@
         </p:nvSpPr>
         <p:spPr>
           <a:xfrm>
-            <a:off x="6903720" y="2286000"/>
-            <a:ext cx="4647895" cy="457200"/>
+            <a:off x="640080" y="2240280"/>
+            <a:ext cx="5760720" cy="365760"/>
           </a:xfrm>
           <a:prstGeom prst="rect">
             <a:avLst/>
@@ -8839,13 +8752,13 @@
               </a:spcAft>
             </a:pPr>
             <a:r>
-              <a:rPr sz="2400" b="1" i="0">
-                <a:solidFill>
-                  <a:srgbClr val="0E5E63"/>
-                </a:solidFill>
-                <a:latin typeface="Arial"/>
-              </a:rPr>
-              <a:t>NCT03232892</a:t>
+              <a:rPr sz="1400" b="0" i="0">
+                <a:solidFill>
+                  <a:srgbClr val="5C6A70"/>
+                </a:solidFill>
+                <a:latin typeface="Arial"/>
+              </a:rPr>
+              <a:t>Top 3 flags: share of virtual patients each rule excludes on its own</a:t>
             </a:r>
           </a:p>
         </p:txBody>
@@ -8858,8 +8771,8 @@
         </p:nvSpPr>
         <p:spPr>
           <a:xfrm>
-            <a:off x="6903720" y="2788920"/>
-            <a:ext cx="4647895" cy="457200"/>
+            <a:off x="640080" y="5440680"/>
+            <a:ext cx="5760720" cy="365760"/>
           </a:xfrm>
           <a:prstGeom prst="rect">
             <a:avLst/>
@@ -8879,13 +8792,13 @@
               </a:spcAft>
             </a:pPr>
             <a:r>
-              <a:rPr sz="1600" b="0" i="0">
-                <a:solidFill>
-                  <a:srgbClr val="5C6A70"/>
-                </a:solidFill>
-                <a:latin typeface="Arial"/>
-              </a:rPr>
-              <a:t>Terminated 2019-09-11: “Low Accrual”</a:t>
+              <a:rPr sz="1400" b="0" i="0">
+                <a:solidFill>
+                  <a:srgbClr val="C8492F"/>
+                </a:solidFill>
+                <a:latin typeface="Arial"/>
+              </a:rPr>
+              <a:t>Coral: the rule the sponsor later removed</a:t>
             </a:r>
           </a:p>
         </p:txBody>
@@ -8898,8 +8811,8 @@
         </p:nvSpPr>
         <p:spPr>
           <a:xfrm>
-            <a:off x="6903720" y="3474720"/>
-            <a:ext cx="4647895" cy="2194560"/>
+            <a:off x="6812280" y="2194560"/>
+            <a:ext cx="4739335" cy="457200"/>
           </a:xfrm>
           <a:prstGeom prst="rect">
             <a:avLst/>
@@ -8910,12 +8823,92 @@
           <a:bodyPr wrap="square" lIns="0" rIns="0" tIns="0" bIns="0" anchor="t"/>
           <a:lstStyle/>
           <a:p>
-            <a:pPr algn="l" marL="251460" indent="-251460">
+            <a:pPr algn="l">
               <a:lnSpc>
                 <a:spcPct val="110000"/>
               </a:lnSpc>
               <a:spcAft>
-                <a:spcPts val="1350"/>
+                <a:spcPts val="0"/>
+              </a:spcAft>
+            </a:pPr>
+            <a:r>
+              <a:rPr sz="2400" b="1" i="0">
+                <a:solidFill>
+                  <a:srgbClr val="0E5E63"/>
+                </a:solidFill>
+                <a:latin typeface="Arial"/>
+              </a:rPr>
+              <a:t>NCT03232892</a:t>
+            </a:r>
+          </a:p>
+        </p:txBody>
+      </p:sp>
+      <p:sp>
+        <p:nvSpPr>
+          <p:cNvPr id="6" name="TextBox 5"/>
+          <p:cNvSpPr txBox="1"/>
+          <p:nvPr/>
+        </p:nvSpPr>
+        <p:spPr>
+          <a:xfrm>
+            <a:off x="6812280" y="2697480"/>
+            <a:ext cx="4739335" cy="365760"/>
+          </a:xfrm>
+          <a:prstGeom prst="rect">
+            <a:avLst/>
+          </a:prstGeom>
+          <a:noFill/>
+        </p:spPr>
+        <p:txBody>
+          <a:bodyPr wrap="square" lIns="0" rIns="0" tIns="0" bIns="0" anchor="t"/>
+          <a:lstStyle/>
+          <a:p>
+            <a:pPr algn="l">
+              <a:lnSpc>
+                <a:spcPct val="110000"/>
+              </a:lnSpc>
+              <a:spcAft>
+                <a:spcPts val="0"/>
+              </a:spcAft>
+            </a:pPr>
+            <a:r>
+              <a:rPr sz="1600" b="0" i="0">
+                <a:solidFill>
+                  <a:srgbClr val="5C6A70"/>
+                </a:solidFill>
+                <a:latin typeface="Arial"/>
+              </a:rPr>
+              <a:t>Terminated 2019-09-11: “Low Accrual”</a:t>
+            </a:r>
+          </a:p>
+        </p:txBody>
+      </p:sp>
+      <p:sp>
+        <p:nvSpPr>
+          <p:cNvPr id="7" name="TextBox 6"/>
+          <p:cNvSpPr txBox="1"/>
+          <p:nvPr/>
+        </p:nvSpPr>
+        <p:spPr>
+          <a:xfrm>
+            <a:off x="6812280" y="3291840"/>
+            <a:ext cx="4739335" cy="2926080"/>
+          </a:xfrm>
+          <a:prstGeom prst="rect">
+            <a:avLst/>
+          </a:prstGeom>
+          <a:noFill/>
+        </p:spPr>
+        <p:txBody>
+          <a:bodyPr wrap="square" lIns="0" rIns="0" tIns="0" bIns="0" anchor="t"/>
+          <a:lstStyle/>
+          <a:p>
+            <a:pPr algn="l" marL="223520" indent="-223520">
+              <a:lnSpc>
+                <a:spcPct val="110000"/>
+              </a:lnSpc>
+              <a:spcAft>
+                <a:spcPts val="1200"/>
               </a:spcAft>
               <a:buClr>
                 <a:srgbClr val="2E8A8F"/>
@@ -8925,22 +8918,22 @@
               <a:buChar char="•"/>
             </a:pPr>
             <a:r>
-              <a:rPr sz="1800" b="0" i="0">
+              <a:rPr sz="1600" b="0" i="0">
                 <a:solidFill>
                   <a:srgbClr val="1B2A30"/>
                 </a:solidFill>
                 <a:latin typeface="Arial"/>
               </a:rPr>
-              <a:t>21.4% of 1,000 virtual patients pass the first registered criteria</a:t>
-            </a:r>
-          </a:p>
-          <a:p>
-            <a:pPr algn="l" marL="251460" indent="-251460">
+              <a:t>Flag #1: prior platinum therapy (I3), the rule the sponsor later removed; alone it excludes 63%</a:t>
+            </a:r>
+          </a:p>
+          <a:p>
+            <a:pPr algn="l" marL="223520" indent="-223520">
               <a:lnSpc>
                 <a:spcPct val="110000"/>
               </a:lnSpc>
               <a:spcAft>
-                <a:spcPts val="1350"/>
+                <a:spcPts val="1200"/>
               </a:spcAft>
               <a:buClr>
                 <a:srgbClr val="2E8A8F"/>
@@ -8950,22 +8943,22 @@
               <a:buChar char="•"/>
             </a:pPr>
             <a:r>
-              <a:rPr sz="1800" b="0" i="0">
+              <a:rPr sz="1600" b="0" i="0">
                 <a:solidFill>
                   <a:srgbClr val="1B2A30"/>
                 </a:solidFill>
                 <a:latin typeface="Arial"/>
               </a:rPr>
-              <a:t>ECOG &lt;= 1 excludes the most (35%)</a:t>
-            </a:r>
-          </a:p>
-          <a:p>
-            <a:pPr algn="l" marL="251460" indent="-251460">
+              <a:t>Flags rank rules by how many virtual patients each excludes; the risk model does not read criteria</a:t>
+            </a:r>
+          </a:p>
+          <a:p>
+            <a:pPr algn="l" marL="223520" indent="-223520">
               <a:lnSpc>
                 <a:spcPct val="110000"/>
               </a:lnSpc>
               <a:spcAft>
-                <a:spcPts val="1350"/>
+                <a:spcPts val="1200"/>
               </a:spcAft>
               <a:buClr>
                 <a:srgbClr val="2E8A8F"/>
@@ -8975,60 +8968,20 @@
               <a:buChar char="•"/>
             </a:pPr>
             <a:r>
-              <a:rPr sz="1800" b="0" i="0">
+              <a:rPr sz="1600" b="0" i="0">
                 <a:solidFill>
                   <a:srgbClr val="1B2A30"/>
                 </a:solidFill>
                 <a:latin typeface="Arial"/>
               </a:rPr>
-              <a:t>Did our top 3 flags include the widened rule? [TBD: demo flags (docs/deck/data/demo.json)]</a:t>
-            </a:r>
-          </a:p>
-        </p:txBody>
-      </p:sp>
-      <p:sp>
-        <p:nvSpPr>
-          <p:cNvPr id="6" name="TextBox 5"/>
-          <p:cNvSpPr txBox="1"/>
-          <p:nvPr/>
-        </p:nvSpPr>
-        <p:spPr>
-          <a:xfrm>
-            <a:off x="6903720" y="5715000"/>
-            <a:ext cx="4647895" cy="365760"/>
-          </a:xfrm>
-          <a:prstGeom prst="rect">
-            <a:avLst/>
-          </a:prstGeom>
-          <a:noFill/>
-        </p:spPr>
-        <p:txBody>
-          <a:bodyPr wrap="square" lIns="0" rIns="0" tIns="0" bIns="0" anchor="t"/>
-          <a:lstStyle/>
-          <a:p>
-            <a:pPr algn="l">
-              <a:lnSpc>
-                <a:spcPct val="110000"/>
-              </a:lnSpc>
-              <a:spcAft>
-                <a:spcPts val="0"/>
-              </a:spcAft>
-            </a:pPr>
-            <a:r>
-              <a:rPr sz="1300" b="0" i="0">
-                <a:solidFill>
-                  <a:srgbClr val="C8492F"/>
-                </a:solidFill>
-                <a:latin typeface="Arial"/>
-              </a:rPr>
-              <a:t>Coral bars: rules the sponsor later widened</a:t>
-            </a:r>
-          </a:p>
-        </p:txBody>
-      </p:sp>
-      <p:sp>
-        <p:nvSpPr>
-          <p:cNvPr id="7" name="TextBox 6"/>
+              <a:t>Honest miss: predicted accrual-failure risk 7% (range 6% to 12%), the 50th percentile of test trials</a:t>
+            </a:r>
+          </a:p>
+        </p:txBody>
+      </p:sp>
+      <p:sp>
+        <p:nvSpPr>
+          <p:cNvPr id="8" name="TextBox 7"/>
           <p:cNvSpPr txBox="1"/>
           <p:nvPr/>
         </p:nvSpPr>
@@ -9068,7 +9021,7 @@
       </p:sp>
       <p:sp>
         <p:nvSpPr>
-          <p:cNvPr id="8" name="Title"/>
+          <p:cNvPr id="9" name="Title"/>
           <p:cNvSpPr txBox="1"/>
           <p:nvPr/>
         </p:nvSpPr>
@@ -9101,14 +9054,14 @@
                 </a:solidFill>
                 <a:latin typeface="Arial"/>
               </a:rPr>
-              <a:t>Backtest: from NCT03232892's first protocol, Clinova finds where enrollment stalls</a:t>
-            </a:r>
-          </a:p>
-        </p:txBody>
-      </p:sp>
-      <p:sp>
-        <p:nvSpPr>
-          <p:cNvPr id="9" name="TextBox 8"/>
+              <a:t>Given only its first protocol, Clinova's flag #1 was the rule the sponsor later removed</a:t>
+            </a:r>
+          </a:p>
+        </p:txBody>
+      </p:sp>
+      <p:sp>
+        <p:nvSpPr>
+          <p:cNvPr id="10" name="TextBox 9"/>
           <p:cNvSpPr txBox="1"/>
           <p:nvPr/>
         </p:nvSpPr>
@@ -9148,7 +9101,7 @@
       </p:sp>
       <p:sp>
         <p:nvSpPr>
-          <p:cNvPr id="10" name="TextBox 9"/>
+          <p:cNvPr id="11" name="TextBox 10"/>
           <p:cNvSpPr txBox="1"/>
           <p:nvPr/>
         </p:nvSpPr>
@@ -9181,47 +9134,7 @@
                 </a:solidFill>
                 <a:latin typeface="Arial"/>
               </a:rPr>
-              <a:t>Sources: docs/demo_trial.md, docs/gate1_e2e.json (seed 1), docs/deck/data/demo.json</a:t>
-            </a:r>
-          </a:p>
-        </p:txBody>
-      </p:sp>
-      <p:sp>
-        <p:nvSpPr>
-          <p:cNvPr id="11" name="Rounded Rectangle 10"/>
-          <p:cNvSpPr/>
-          <p:nvPr/>
-        </p:nvSpPr>
-        <p:spPr>
-          <a:xfrm>
-            <a:off x="8534095" y="384048"/>
-            <a:ext cx="3017520" cy="384048"/>
-          </a:xfrm>
-          <a:prstGeom prst="roundRect">
-            <a:avLst>
-              <a:gd name="adj" fmla="val 30000"/>
-            </a:avLst>
-          </a:prstGeom>
-          <a:solidFill>
-            <a:srgbClr val="C8492F"/>
-          </a:solidFill>
-          <a:ln>
-            <a:noFill/>
-          </a:ln>
-        </p:spPr>
-        <p:txBody>
-          <a:bodyPr rtlCol="0" anchor="ctr" tIns="0" bIns="0"/>
-          <a:lstStyle/>
-          <a:p>
-            <a:pPr algn="ctr"/>
-            <a:r>
-              <a:rPr sz="1200" b="1">
-                <a:solidFill>
-                  <a:srgbClr val="FFFFFF"/>
-                </a:solidFill>
-                <a:latin typeface="Arial"/>
-              </a:rPr>
-              <a:t>DRAFT: placeholder numbers</a:t>
+              <a:t>Sources: docs/demo_trial.md, docs/demo_results/NCT03232892.json</a:t>
             </a:r>
           </a:p>
         </p:txBody>
@@ -9373,7 +9286,7 @@
                 </a:solidFill>
                 <a:latin typeface="Arial"/>
               </a:rPr>
-              <a:t>Risk: calibrated probability with a range and top drivers in plain words</a:t>
+              <a:t>Risk: probability with a range, a confidence badge and top drivers in plain words</a:t>
             </a:r>
           </a:p>
           <a:p>
@@ -9478,7 +9391,7 @@
                 </a:solidFill>
                 <a:latin typeface="Arial"/>
               </a:rPr>
-              <a:t>One screen shows the funnel, the calibrated risk and three fixes</a:t>
+              <a:t>One screen shows the funnel, the risk and three fixes</a:t>
             </a:r>
           </a:p>
         </p:txBody>
@@ -9597,265 +9510,1601 @@
         </p:nvSpPr>
         <p:spPr>
           <a:xfrm>
-            <a:off x="640080" y="2331720"/>
-            <a:ext cx="10911535" cy="3291840"/>
+            <a:off x="640080" y="2240280"/>
+            <a:ext cx="3429000" cy="3383280"/>
           </a:xfrm>
           <a:prstGeom prst="roundRect">
             <a:avLst>
-              <a:gd name="adj" fmla="val 4000"/>
+              <a:gd name="adj" fmla="val 8000"/>
             </a:avLst>
           </a:prstGeom>
-          <a:noFill/>
-          <a:ln w="15875">
-            <a:solidFill>
-              <a:srgbClr val="C8492F"/>
-            </a:solidFill>
-          </a:ln>
-        </p:spPr>
-        <p:txBody>
-          <a:bodyPr rtlCol="0" anchor="ctr"/>
-          <a:lstStyle/>
-          <a:p>
-            <a:pPr algn="ctr"/>
-          </a:p>
-        </p:txBody>
-      </p:sp>
-      <p:sp>
-        <p:nvSpPr>
-          <p:cNvPr id="3" name="TextBox 2"/>
-          <p:cNvSpPr txBox="1"/>
-          <p:nvPr/>
-        </p:nvSpPr>
-        <p:spPr>
-          <a:xfrm>
-            <a:off x="914400" y="2331720"/>
-            <a:ext cx="10362895" cy="3291840"/>
-          </a:xfrm>
-          <a:prstGeom prst="rect">
-            <a:avLst/>
-          </a:prstGeom>
-          <a:noFill/>
-        </p:spPr>
-        <p:txBody>
-          <a:bodyPr wrap="square" lIns="0" rIns="0" tIns="0" bIns="0" anchor="ctr"/>
-          <a:lstStyle/>
-          <a:p>
-            <a:pPr algn="ctr">
-              <a:lnSpc>
-                <a:spcPct val="110000"/>
-              </a:lnSpc>
-              <a:spcAft>
-                <a:spcPts val="0"/>
-              </a:spcAft>
-            </a:pPr>
-            <a:r>
-              <a:rPr sz="1800" b="0" i="0">
-                <a:solidFill>
-                  <a:srgbClr val="C8492F"/>
-                </a:solidFill>
-                <a:latin typeface="Arial"/>
-              </a:rPr>
-              <a:t>[TBD: demo fixes from docs/deck/data/demo.json]</a:t>
-            </a:r>
-          </a:p>
-        </p:txBody>
-      </p:sp>
-      <p:sp>
-        <p:nvSpPr>
-          <p:cNvPr id="4" name="TextBox 3"/>
-          <p:cNvSpPr txBox="1"/>
-          <p:nvPr/>
-        </p:nvSpPr>
-        <p:spPr>
-          <a:xfrm>
-            <a:off x="640080" y="457200"/>
-            <a:ext cx="8229600" cy="320040"/>
-          </a:xfrm>
-          <a:prstGeom prst="rect">
-            <a:avLst/>
-          </a:prstGeom>
-          <a:noFill/>
-        </p:spPr>
-        <p:txBody>
-          <a:bodyPr wrap="square" lIns="0" rIns="0" tIns="0" bIns="0" anchor="t"/>
-          <a:lstStyle/>
-          <a:p>
-            <a:pPr algn="l">
-              <a:lnSpc>
-                <a:spcPct val="110000"/>
-              </a:lnSpc>
-              <a:spcAft>
-                <a:spcPts val="0"/>
-              </a:spcAft>
-            </a:pPr>
-            <a:r>
-              <a:rPr sz="1300" b="1" i="0">
-                <a:solidFill>
-                  <a:srgbClr val="2E8A8F"/>
-                </a:solidFill>
-                <a:latin typeface="Arial"/>
-              </a:rPr>
-              <a:t>OPTIMIZER</a:t>
-            </a:r>
-          </a:p>
-        </p:txBody>
-      </p:sp>
-      <p:sp>
-        <p:nvSpPr>
-          <p:cNvPr id="5" name="Title"/>
-          <p:cNvSpPr txBox="1"/>
-          <p:nvPr/>
-        </p:nvSpPr>
-        <p:spPr>
-          <a:xfrm>
-            <a:off x="640080" y="868680"/>
-            <a:ext cx="10911535" cy="1143000"/>
-          </a:xfrm>
-          <a:prstGeom prst="rect">
-            <a:avLst/>
-          </a:prstGeom>
-          <a:noFill/>
-        </p:spPr>
-        <p:txBody>
-          <a:bodyPr wrap="square" lIns="0" rIns="0" tIns="0" bIns="0" anchor="t"/>
-          <a:lstStyle/>
-          <a:p>
-            <a:pPr algn="l">
-              <a:lnSpc>
-                <a:spcPct val="105000"/>
-              </a:lnSpc>
-              <a:spcAft>
-                <a:spcPts val="0"/>
-              </a:spcAft>
-            </a:pPr>
-            <a:r>
-              <a:rPr sz="3000" b="1" i="0">
-                <a:solidFill>
-                  <a:srgbClr val="1B2A30"/>
-                </a:solidFill>
-                <a:latin typeface="Arial"/>
-              </a:rPr>
-              <a:t>The optimizer proposes three trade-offs, each with a range and a dollar value</a:t>
-            </a:r>
-          </a:p>
-        </p:txBody>
-      </p:sp>
-      <p:sp>
-        <p:nvSpPr>
-          <p:cNvPr id="6" name="TextBox 5"/>
-          <p:cNvSpPr txBox="1"/>
-          <p:nvPr/>
-        </p:nvSpPr>
-        <p:spPr>
-          <a:xfrm>
-            <a:off x="10637215" y="6400800"/>
-            <a:ext cx="914400" cy="274320"/>
-          </a:xfrm>
-          <a:prstGeom prst="rect">
-            <a:avLst/>
-          </a:prstGeom>
-          <a:noFill/>
-        </p:spPr>
-        <p:txBody>
-          <a:bodyPr wrap="square" lIns="0" rIns="0" tIns="0" bIns="0" anchor="t"/>
-          <a:lstStyle/>
-          <a:p>
-            <a:pPr algn="r">
-              <a:lnSpc>
-                <a:spcPct val="110000"/>
-              </a:lnSpc>
-              <a:spcAft>
-                <a:spcPts val="0"/>
-              </a:spcAft>
-            </a:pPr>
-            <a:r>
-              <a:rPr sz="1100" b="0" i="0">
-                <a:solidFill>
-                  <a:srgbClr val="A9B4B8"/>
-                </a:solidFill>
-                <a:latin typeface="Arial"/>
-              </a:rPr>
-              <a:t>7 / 12</a:t>
-            </a:r>
-          </a:p>
-        </p:txBody>
-      </p:sp>
-      <p:sp>
-        <p:nvSpPr>
-          <p:cNvPr id="7" name="TextBox 6"/>
-          <p:cNvSpPr txBox="1"/>
-          <p:nvPr/>
-        </p:nvSpPr>
-        <p:spPr>
-          <a:xfrm>
-            <a:off x="640080" y="6400800"/>
-            <a:ext cx="8686800" cy="274320"/>
-          </a:xfrm>
-          <a:prstGeom prst="rect">
-            <a:avLst/>
-          </a:prstGeom>
-          <a:noFill/>
-        </p:spPr>
-        <p:txBody>
-          <a:bodyPr wrap="square" lIns="0" rIns="0" tIns="0" bIns="0" anchor="t"/>
-          <a:lstStyle/>
-          <a:p>
-            <a:pPr algn="l">
-              <a:lnSpc>
-                <a:spcPct val="110000"/>
-              </a:lnSpc>
-              <a:spcAft>
-                <a:spcPts val="0"/>
-              </a:spcAft>
-            </a:pPr>
-            <a:r>
-              <a:rPr sz="1000" b="0" i="0">
-                <a:solidFill>
-                  <a:srgbClr val="A9B4B8"/>
-                </a:solidFill>
-                <a:latin typeface="Arial"/>
-              </a:rPr>
-              <a:t>Sources: docs/deck/data/demo.json</a:t>
-            </a:r>
-          </a:p>
-        </p:txBody>
-      </p:sp>
-      <p:sp>
-        <p:nvSpPr>
-          <p:cNvPr id="8" name="Rounded Rectangle 7"/>
-          <p:cNvSpPr/>
-          <p:nvPr/>
-        </p:nvSpPr>
-        <p:spPr>
-          <a:xfrm>
-            <a:off x="8534095" y="384048"/>
-            <a:ext cx="3017520" cy="384048"/>
-          </a:xfrm>
-          <a:prstGeom prst="roundRect">
-            <a:avLst>
-              <a:gd name="adj" fmla="val 30000"/>
-            </a:avLst>
-          </a:prstGeom>
           <a:solidFill>
-            <a:srgbClr val="C8492F"/>
+            <a:srgbClr val="E9F2F2"/>
           </a:solidFill>
           <a:ln>
             <a:noFill/>
           </a:ln>
         </p:spPr>
         <p:txBody>
-          <a:bodyPr rtlCol="0" anchor="ctr" tIns="0" bIns="0"/>
+          <a:bodyPr rtlCol="0" anchor="ctr"/>
           <a:lstStyle/>
           <a:p>
             <a:pPr algn="ctr"/>
-            <a:r>
-              <a:rPr sz="1200" b="1">
-                <a:solidFill>
-                  <a:srgbClr val="FFFFFF"/>
-                </a:solidFill>
-                <a:latin typeface="Arial"/>
-              </a:rPr>
-              <a:t>DRAFT: placeholder numbers</a:t>
+          </a:p>
+        </p:txBody>
+      </p:sp>
+      <p:sp>
+        <p:nvSpPr>
+          <p:cNvPr id="3" name="TextBox 2"/>
+          <p:cNvSpPr txBox="1"/>
+          <p:nvPr/>
+        </p:nvSpPr>
+        <p:spPr>
+          <a:xfrm>
+            <a:off x="914400" y="2468880"/>
+            <a:ext cx="2880360" cy="411480"/>
+          </a:xfrm>
+          <a:prstGeom prst="rect">
+            <a:avLst/>
+          </a:prstGeom>
+          <a:noFill/>
+        </p:spPr>
+        <p:txBody>
+          <a:bodyPr wrap="square" lIns="0" rIns="0" tIns="0" bIns="0" anchor="t"/>
+          <a:lstStyle/>
+          <a:p>
+            <a:pPr algn="l">
+              <a:lnSpc>
+                <a:spcPct val="110000"/>
+              </a:lnSpc>
+              <a:spcAft>
+                <a:spcPts val="0"/>
+              </a:spcAft>
+            </a:pPr>
+            <a:r>
+              <a:rPr sz="2100" b="1" i="0">
+                <a:solidFill>
+                  <a:srgbClr val="0E5E63"/>
+                </a:solidFill>
+                <a:latin typeface="Arial"/>
+              </a:rPr>
+              <a:t>Fastest enrollment</a:t>
+            </a:r>
+          </a:p>
+        </p:txBody>
+      </p:sp>
+      <p:sp>
+        <p:nvSpPr>
+          <p:cNvPr id="4" name="TextBox 3"/>
+          <p:cNvSpPr txBox="1"/>
+          <p:nvPr/>
+        </p:nvSpPr>
+        <p:spPr>
+          <a:xfrm>
+            <a:off x="914400" y="2971800"/>
+            <a:ext cx="2880360" cy="1188720"/>
+          </a:xfrm>
+          <a:prstGeom prst="rect">
+            <a:avLst/>
+          </a:prstGeom>
+          <a:noFill/>
+        </p:spPr>
+        <p:txBody>
+          <a:bodyPr wrap="square" lIns="0" rIns="0" tIns="0" bIns="0" anchor="t"/>
+          <a:lstStyle/>
+          <a:p>
+            <a:pPr algn="l">
+              <a:lnSpc>
+                <a:spcPct val="105000"/>
+              </a:lnSpc>
+              <a:spcAft>
+                <a:spcPts val="0"/>
+              </a:spcAft>
+            </a:pPr>
+            <a:r>
+              <a:rPr sz="1400" b="0" i="0">
+                <a:solidFill>
+                  <a:srgbClr val="5C6A70"/>
+                </a:solidFill>
+                <a:latin typeface="Arial"/>
+              </a:rPr>
+              <a:t>Widen histology rule (I1)</a:t>
+            </a:r>
+          </a:p>
+          <a:p>
+            <a:pPr algn="l">
+              <a:lnSpc>
+                <a:spcPct val="105000"/>
+              </a:lnSpc>
+              <a:spcAft>
+                <a:spcPts val="0"/>
+              </a:spcAft>
+            </a:pPr>
+            <a:r>
+              <a:rPr sz="1400" b="0" i="0">
+                <a:solidFill>
+                  <a:srgbClr val="5C6A70"/>
+                </a:solidFill>
+                <a:latin typeface="Arial"/>
+              </a:rPr>
+              <a:t>Lift ECOG limit (I6)</a:t>
+            </a:r>
+          </a:p>
+          <a:p>
+            <a:pPr algn="l">
+              <a:lnSpc>
+                <a:spcPct val="105000"/>
+              </a:lnSpc>
+              <a:spcAft>
+                <a:spcPts val="0"/>
+              </a:spcAft>
+            </a:pPr>
+            <a:r>
+              <a:rPr sz="1400" b="0" i="0">
+                <a:solidFill>
+                  <a:srgbClr val="5C6A70"/>
+                </a:solidFill>
+                <a:latin typeface="Arial"/>
+              </a:rPr>
+              <a:t>CrCl (I14): ≥ 50 to ≥ 20 mL/min</a:t>
+            </a:r>
+          </a:p>
+        </p:txBody>
+      </p:sp>
+      <p:sp>
+        <p:nvSpPr>
+          <p:cNvPr id="5" name="TextBox 4"/>
+          <p:cNvSpPr txBox="1"/>
+          <p:nvPr/>
+        </p:nvSpPr>
+        <p:spPr>
+          <a:xfrm>
+            <a:off x="914400" y="3977639"/>
+            <a:ext cx="1645920" cy="320040"/>
+          </a:xfrm>
+          <a:prstGeom prst="rect">
+            <a:avLst/>
+          </a:prstGeom>
+          <a:noFill/>
+        </p:spPr>
+        <p:txBody>
+          <a:bodyPr wrap="square" lIns="0" rIns="0" tIns="0" bIns="0" anchor="t"/>
+          <a:lstStyle/>
+          <a:p>
+            <a:pPr algn="l">
+              <a:lnSpc>
+                <a:spcPct val="110000"/>
+              </a:lnSpc>
+              <a:spcAft>
+                <a:spcPts val="0"/>
+              </a:spcAft>
+            </a:pPr>
+            <a:r>
+              <a:rPr sz="1500" b="0" i="0">
+                <a:solidFill>
+                  <a:srgbClr val="1B2A30"/>
+                </a:solidFill>
+                <a:latin typeface="Arial"/>
+              </a:rPr>
+              <a:t>Enrollment speed</a:t>
+            </a:r>
+          </a:p>
+        </p:txBody>
+      </p:sp>
+      <p:sp>
+        <p:nvSpPr>
+          <p:cNvPr id="6" name="TextBox 5"/>
+          <p:cNvSpPr txBox="1"/>
+          <p:nvPr/>
+        </p:nvSpPr>
+        <p:spPr>
+          <a:xfrm>
+            <a:off x="2377439" y="3977639"/>
+            <a:ext cx="1417319" cy="320040"/>
+          </a:xfrm>
+          <a:prstGeom prst="rect">
+            <a:avLst/>
+          </a:prstGeom>
+          <a:noFill/>
+        </p:spPr>
+        <p:txBody>
+          <a:bodyPr wrap="square" lIns="0" rIns="0" tIns="0" bIns="0" anchor="t"/>
+          <a:lstStyle/>
+          <a:p>
+            <a:pPr algn="r">
+              <a:lnSpc>
+                <a:spcPct val="110000"/>
+              </a:lnSpc>
+              <a:spcAft>
+                <a:spcPts val="0"/>
+              </a:spcAft>
+            </a:pPr>
+            <a:r>
+              <a:rPr sz="1700" b="1" i="0">
+                <a:solidFill>
+                  <a:srgbClr val="1B2A30"/>
+                </a:solidFill>
+                <a:latin typeface="Arial"/>
+              </a:rPr>
+              <a:t>+101%</a:t>
+            </a:r>
+          </a:p>
+        </p:txBody>
+      </p:sp>
+      <p:sp>
+        <p:nvSpPr>
+          <p:cNvPr id="7" name="TextBox 6"/>
+          <p:cNvSpPr txBox="1"/>
+          <p:nvPr/>
+        </p:nvSpPr>
+        <p:spPr>
+          <a:xfrm>
+            <a:off x="1920239" y="4270248"/>
+            <a:ext cx="1874519" cy="274320"/>
+          </a:xfrm>
+          <a:prstGeom prst="rect">
+            <a:avLst/>
+          </a:prstGeom>
+          <a:noFill/>
+        </p:spPr>
+        <p:txBody>
+          <a:bodyPr wrap="square" lIns="0" rIns="0" tIns="0" bIns="0" anchor="t"/>
+          <a:lstStyle/>
+          <a:p>
+            <a:pPr algn="r">
+              <a:lnSpc>
+                <a:spcPct val="110000"/>
+              </a:lnSpc>
+              <a:spcAft>
+                <a:spcPts val="0"/>
+              </a:spcAft>
+            </a:pPr>
+            <a:r>
+              <a:rPr sz="1200" b="0" i="0">
+                <a:solidFill>
+                  <a:srgbClr val="5C6A70"/>
+                </a:solidFill>
+                <a:latin typeface="Arial"/>
+              </a:rPr>
+              <a:t>+98% to +137%</a:t>
+            </a:r>
+          </a:p>
+        </p:txBody>
+      </p:sp>
+      <p:sp>
+        <p:nvSpPr>
+          <p:cNvPr id="8" name="TextBox 7"/>
+          <p:cNvSpPr txBox="1"/>
+          <p:nvPr/>
+        </p:nvSpPr>
+        <p:spPr>
+          <a:xfrm>
+            <a:off x="914400" y="4544568"/>
+            <a:ext cx="1645920" cy="320040"/>
+          </a:xfrm>
+          <a:prstGeom prst="rect">
+            <a:avLst/>
+          </a:prstGeom>
+          <a:noFill/>
+        </p:spPr>
+        <p:txBody>
+          <a:bodyPr wrap="square" lIns="0" rIns="0" tIns="0" bIns="0" anchor="t"/>
+          <a:lstStyle/>
+          <a:p>
+            <a:pPr algn="l">
+              <a:lnSpc>
+                <a:spcPct val="110000"/>
+              </a:lnSpc>
+              <a:spcAft>
+                <a:spcPts val="0"/>
+              </a:spcAft>
+            </a:pPr>
+            <a:r>
+              <a:rPr sz="1500" b="0" i="0">
+                <a:solidFill>
+                  <a:srgbClr val="1B2A30"/>
+                </a:solidFill>
+                <a:latin typeface="Arial"/>
+              </a:rPr>
+              <a:t>Dropout</a:t>
+            </a:r>
+          </a:p>
+        </p:txBody>
+      </p:sp>
+      <p:sp>
+        <p:nvSpPr>
+          <p:cNvPr id="9" name="TextBox 8"/>
+          <p:cNvSpPr txBox="1"/>
+          <p:nvPr/>
+        </p:nvSpPr>
+        <p:spPr>
+          <a:xfrm>
+            <a:off x="2377439" y="4544568"/>
+            <a:ext cx="1417319" cy="320040"/>
+          </a:xfrm>
+          <a:prstGeom prst="rect">
+            <a:avLst/>
+          </a:prstGeom>
+          <a:noFill/>
+        </p:spPr>
+        <p:txBody>
+          <a:bodyPr wrap="square" lIns="0" rIns="0" tIns="0" bIns="0" anchor="t"/>
+          <a:lstStyle/>
+          <a:p>
+            <a:pPr algn="r">
+              <a:lnSpc>
+                <a:spcPct val="110000"/>
+              </a:lnSpc>
+              <a:spcAft>
+                <a:spcPts val="0"/>
+              </a:spcAft>
+            </a:pPr>
+            <a:r>
+              <a:rPr sz="1700" b="1" i="0">
+                <a:solidFill>
+                  <a:srgbClr val="1B2A30"/>
+                </a:solidFill>
+                <a:latin typeface="Arial"/>
+              </a:rPr>
+              <a:t>+4.4 pts</a:t>
+            </a:r>
+          </a:p>
+        </p:txBody>
+      </p:sp>
+      <p:sp>
+        <p:nvSpPr>
+          <p:cNvPr id="10" name="TextBox 9"/>
+          <p:cNvSpPr txBox="1"/>
+          <p:nvPr/>
+        </p:nvSpPr>
+        <p:spPr>
+          <a:xfrm>
+            <a:off x="1920239" y="4837176"/>
+            <a:ext cx="1874519" cy="274320"/>
+          </a:xfrm>
+          <a:prstGeom prst="rect">
+            <a:avLst/>
+          </a:prstGeom>
+          <a:noFill/>
+        </p:spPr>
+        <p:txBody>
+          <a:bodyPr wrap="square" lIns="0" rIns="0" tIns="0" bIns="0" anchor="t"/>
+          <a:lstStyle/>
+          <a:p>
+            <a:pPr algn="r">
+              <a:lnSpc>
+                <a:spcPct val="110000"/>
+              </a:lnSpc>
+              <a:spcAft>
+                <a:spcPts val="0"/>
+              </a:spcAft>
+            </a:pPr>
+            <a:r>
+              <a:rPr sz="1200" b="0" i="0">
+                <a:solidFill>
+                  <a:srgbClr val="5C6A70"/>
+                </a:solidFill>
+                <a:latin typeface="Arial"/>
+              </a:rPr>
+              <a:t>+4.4 pts to +6.8 pts</a:t>
+            </a:r>
+          </a:p>
+        </p:txBody>
+      </p:sp>
+      <p:sp>
+        <p:nvSpPr>
+          <p:cNvPr id="11" name="TextBox 10"/>
+          <p:cNvSpPr txBox="1"/>
+          <p:nvPr/>
+        </p:nvSpPr>
+        <p:spPr>
+          <a:xfrm>
+            <a:off x="914400" y="5111496"/>
+            <a:ext cx="1645920" cy="320040"/>
+          </a:xfrm>
+          <a:prstGeom prst="rect">
+            <a:avLst/>
+          </a:prstGeom>
+          <a:noFill/>
+        </p:spPr>
+        <p:txBody>
+          <a:bodyPr wrap="square" lIns="0" rIns="0" tIns="0" bIns="0" anchor="t"/>
+          <a:lstStyle/>
+          <a:p>
+            <a:pPr algn="l">
+              <a:lnSpc>
+                <a:spcPct val="110000"/>
+              </a:lnSpc>
+              <a:spcAft>
+                <a:spcPts val="0"/>
+              </a:spcAft>
+            </a:pPr>
+            <a:r>
+              <a:rPr sz="1500" b="0" i="0">
+                <a:solidFill>
+                  <a:srgbClr val="1B2A30"/>
+                </a:solidFill>
+                <a:latin typeface="Arial"/>
+              </a:rPr>
+              <a:t>Diversity index</a:t>
+            </a:r>
+          </a:p>
+        </p:txBody>
+      </p:sp>
+      <p:sp>
+        <p:nvSpPr>
+          <p:cNvPr id="12" name="TextBox 11"/>
+          <p:cNvSpPr txBox="1"/>
+          <p:nvPr/>
+        </p:nvSpPr>
+        <p:spPr>
+          <a:xfrm>
+            <a:off x="2377439" y="5111496"/>
+            <a:ext cx="1417319" cy="320040"/>
+          </a:xfrm>
+          <a:prstGeom prst="rect">
+            <a:avLst/>
+          </a:prstGeom>
+          <a:noFill/>
+        </p:spPr>
+        <p:txBody>
+          <a:bodyPr wrap="square" lIns="0" rIns="0" tIns="0" bIns="0" anchor="t"/>
+          <a:lstStyle/>
+          <a:p>
+            <a:pPr algn="r">
+              <a:lnSpc>
+                <a:spcPct val="110000"/>
+              </a:lnSpc>
+              <a:spcAft>
+                <a:spcPts val="0"/>
+              </a:spcAft>
+            </a:pPr>
+            <a:r>
+              <a:rPr sz="1700" b="1" i="0">
+                <a:solidFill>
+                  <a:srgbClr val="1B2A30"/>
+                </a:solidFill>
+                <a:latin typeface="Arial"/>
+              </a:rPr>
+              <a:t>+0.039</a:t>
+            </a:r>
+          </a:p>
+        </p:txBody>
+      </p:sp>
+      <p:sp>
+        <p:nvSpPr>
+          <p:cNvPr id="13" name="Rounded Rectangle 12"/>
+          <p:cNvSpPr/>
+          <p:nvPr/>
+        </p:nvSpPr>
+        <p:spPr>
+          <a:xfrm>
+            <a:off x="4343400" y="2240280"/>
+            <a:ext cx="3429000" cy="3383280"/>
+          </a:xfrm>
+          <a:prstGeom prst="roundRect">
+            <a:avLst>
+              <a:gd name="adj" fmla="val 8000"/>
+            </a:avLst>
+          </a:prstGeom>
+          <a:solidFill>
+            <a:srgbClr val="E9F2F2"/>
+          </a:solidFill>
+          <a:ln>
+            <a:noFill/>
+          </a:ln>
+        </p:spPr>
+        <p:txBody>
+          <a:bodyPr rtlCol="0" anchor="ctr"/>
+          <a:lstStyle/>
+          <a:p>
+            <a:pPr algn="ctr"/>
+          </a:p>
+        </p:txBody>
+      </p:sp>
+      <p:sp>
+        <p:nvSpPr>
+          <p:cNvPr id="14" name="TextBox 13"/>
+          <p:cNvSpPr txBox="1"/>
+          <p:nvPr/>
+        </p:nvSpPr>
+        <p:spPr>
+          <a:xfrm>
+            <a:off x="4617720" y="2468880"/>
+            <a:ext cx="2880360" cy="411480"/>
+          </a:xfrm>
+          <a:prstGeom prst="rect">
+            <a:avLst/>
+          </a:prstGeom>
+          <a:noFill/>
+        </p:spPr>
+        <p:txBody>
+          <a:bodyPr wrap="square" lIns="0" rIns="0" tIns="0" bIns="0" anchor="t"/>
+          <a:lstStyle/>
+          <a:p>
+            <a:pPr algn="l">
+              <a:lnSpc>
+                <a:spcPct val="110000"/>
+              </a:lnSpc>
+              <a:spcAft>
+                <a:spcPts val="0"/>
+              </a:spcAft>
+            </a:pPr>
+            <a:r>
+              <a:rPr sz="2100" b="1" i="0">
+                <a:solidFill>
+                  <a:srgbClr val="0E5E63"/>
+                </a:solidFill>
+                <a:latin typeface="Arial"/>
+              </a:rPr>
+              <a:t>Fewest dropouts</a:t>
+            </a:r>
+          </a:p>
+        </p:txBody>
+      </p:sp>
+      <p:sp>
+        <p:nvSpPr>
+          <p:cNvPr id="15" name="TextBox 14"/>
+          <p:cNvSpPr txBox="1"/>
+          <p:nvPr/>
+        </p:nvSpPr>
+        <p:spPr>
+          <a:xfrm>
+            <a:off x="4617720" y="2971800"/>
+            <a:ext cx="2880360" cy="1188720"/>
+          </a:xfrm>
+          <a:prstGeom prst="rect">
+            <a:avLst/>
+          </a:prstGeom>
+          <a:noFill/>
+        </p:spPr>
+        <p:txBody>
+          <a:bodyPr wrap="square" lIns="0" rIns="0" tIns="0" bIns="0" anchor="t"/>
+          <a:lstStyle/>
+          <a:p>
+            <a:pPr algn="l">
+              <a:lnSpc>
+                <a:spcPct val="105000"/>
+              </a:lnSpc>
+              <a:spcAft>
+                <a:spcPts val="0"/>
+              </a:spcAft>
+            </a:pPr>
+            <a:r>
+              <a:rPr sz="1400" b="0" i="0">
+                <a:solidFill>
+                  <a:srgbClr val="5C6A70"/>
+                </a:solidFill>
+                <a:latin typeface="Arial"/>
+              </a:rPr>
+              <a:t>Drop bilirubin rule (I11)</a:t>
+            </a:r>
+          </a:p>
+          <a:p>
+            <a:pPr algn="l">
+              <a:lnSpc>
+                <a:spcPct val="105000"/>
+              </a:lnSpc>
+              <a:spcAft>
+                <a:spcPts val="0"/>
+              </a:spcAft>
+            </a:pPr>
+            <a:r>
+              <a:rPr sz="1400" b="0" i="0">
+                <a:solidFill>
+                  <a:srgbClr val="5C6A70"/>
+                </a:solidFill>
+                <a:latin typeface="Arial"/>
+              </a:rPr>
+              <a:t>Drop histology rule (I1)</a:t>
+            </a:r>
+          </a:p>
+          <a:p>
+            <a:pPr algn="l">
+              <a:lnSpc>
+                <a:spcPct val="105000"/>
+              </a:lnSpc>
+              <a:spcAft>
+                <a:spcPts val="0"/>
+              </a:spcAft>
+            </a:pPr>
+            <a:r>
+              <a:rPr sz="1400" b="0" i="0">
+                <a:solidFill>
+                  <a:srgbClr val="5C6A70"/>
+                </a:solidFill>
+                <a:latin typeface="Arial"/>
+              </a:rPr>
+              <a:t>Drop cardiac exclusion (E6)</a:t>
+            </a:r>
+          </a:p>
+        </p:txBody>
+      </p:sp>
+      <p:sp>
+        <p:nvSpPr>
+          <p:cNvPr id="16" name="TextBox 15"/>
+          <p:cNvSpPr txBox="1"/>
+          <p:nvPr/>
+        </p:nvSpPr>
+        <p:spPr>
+          <a:xfrm>
+            <a:off x="4617720" y="3977639"/>
+            <a:ext cx="1645920" cy="320040"/>
+          </a:xfrm>
+          <a:prstGeom prst="rect">
+            <a:avLst/>
+          </a:prstGeom>
+          <a:noFill/>
+        </p:spPr>
+        <p:txBody>
+          <a:bodyPr wrap="square" lIns="0" rIns="0" tIns="0" bIns="0" anchor="t"/>
+          <a:lstStyle/>
+          <a:p>
+            <a:pPr algn="l">
+              <a:lnSpc>
+                <a:spcPct val="110000"/>
+              </a:lnSpc>
+              <a:spcAft>
+                <a:spcPts val="0"/>
+              </a:spcAft>
+            </a:pPr>
+            <a:r>
+              <a:rPr sz="1500" b="0" i="0">
+                <a:solidFill>
+                  <a:srgbClr val="1B2A30"/>
+                </a:solidFill>
+                <a:latin typeface="Arial"/>
+              </a:rPr>
+              <a:t>Enrollment speed</a:t>
+            </a:r>
+          </a:p>
+        </p:txBody>
+      </p:sp>
+      <p:sp>
+        <p:nvSpPr>
+          <p:cNvPr id="17" name="TextBox 16"/>
+          <p:cNvSpPr txBox="1"/>
+          <p:nvPr/>
+        </p:nvSpPr>
+        <p:spPr>
+          <a:xfrm>
+            <a:off x="6080760" y="3977639"/>
+            <a:ext cx="1417319" cy="320040"/>
+          </a:xfrm>
+          <a:prstGeom prst="rect">
+            <a:avLst/>
+          </a:prstGeom>
+          <a:noFill/>
+        </p:spPr>
+        <p:txBody>
+          <a:bodyPr wrap="square" lIns="0" rIns="0" tIns="0" bIns="0" anchor="t"/>
+          <a:lstStyle/>
+          <a:p>
+            <a:pPr algn="r">
+              <a:lnSpc>
+                <a:spcPct val="110000"/>
+              </a:lnSpc>
+              <a:spcAft>
+                <a:spcPts val="0"/>
+              </a:spcAft>
+            </a:pPr>
+            <a:r>
+              <a:rPr sz="1700" b="1" i="0">
+                <a:solidFill>
+                  <a:srgbClr val="1B2A30"/>
+                </a:solidFill>
+                <a:latin typeface="Arial"/>
+              </a:rPr>
+              <a:t>+53%</a:t>
+            </a:r>
+          </a:p>
+        </p:txBody>
+      </p:sp>
+      <p:sp>
+        <p:nvSpPr>
+          <p:cNvPr id="18" name="TextBox 17"/>
+          <p:cNvSpPr txBox="1"/>
+          <p:nvPr/>
+        </p:nvSpPr>
+        <p:spPr>
+          <a:xfrm>
+            <a:off x="5623560" y="4270248"/>
+            <a:ext cx="1874519" cy="274320"/>
+          </a:xfrm>
+          <a:prstGeom prst="rect">
+            <a:avLst/>
+          </a:prstGeom>
+          <a:noFill/>
+        </p:spPr>
+        <p:txBody>
+          <a:bodyPr wrap="square" lIns="0" rIns="0" tIns="0" bIns="0" anchor="t"/>
+          <a:lstStyle/>
+          <a:p>
+            <a:pPr algn="r">
+              <a:lnSpc>
+                <a:spcPct val="110000"/>
+              </a:lnSpc>
+              <a:spcAft>
+                <a:spcPts val="0"/>
+              </a:spcAft>
+            </a:pPr>
+            <a:r>
+              <a:rPr sz="1200" b="0" i="0">
+                <a:solidFill>
+                  <a:srgbClr val="5C6A70"/>
+                </a:solidFill>
+                <a:latin typeface="Arial"/>
+              </a:rPr>
+              <a:t>+51% to +66%</a:t>
+            </a:r>
+          </a:p>
+        </p:txBody>
+      </p:sp>
+      <p:sp>
+        <p:nvSpPr>
+          <p:cNvPr id="19" name="TextBox 18"/>
+          <p:cNvSpPr txBox="1"/>
+          <p:nvPr/>
+        </p:nvSpPr>
+        <p:spPr>
+          <a:xfrm>
+            <a:off x="4617720" y="4544568"/>
+            <a:ext cx="1645920" cy="320040"/>
+          </a:xfrm>
+          <a:prstGeom prst="rect">
+            <a:avLst/>
+          </a:prstGeom>
+          <a:noFill/>
+        </p:spPr>
+        <p:txBody>
+          <a:bodyPr wrap="square" lIns="0" rIns="0" tIns="0" bIns="0" anchor="t"/>
+          <a:lstStyle/>
+          <a:p>
+            <a:pPr algn="l">
+              <a:lnSpc>
+                <a:spcPct val="110000"/>
+              </a:lnSpc>
+              <a:spcAft>
+                <a:spcPts val="0"/>
+              </a:spcAft>
+            </a:pPr>
+            <a:r>
+              <a:rPr sz="1500" b="0" i="0">
+                <a:solidFill>
+                  <a:srgbClr val="1B2A30"/>
+                </a:solidFill>
+                <a:latin typeface="Arial"/>
+              </a:rPr>
+              <a:t>Dropout</a:t>
+            </a:r>
+          </a:p>
+        </p:txBody>
+      </p:sp>
+      <p:sp>
+        <p:nvSpPr>
+          <p:cNvPr id="20" name="TextBox 19"/>
+          <p:cNvSpPr txBox="1"/>
+          <p:nvPr/>
+        </p:nvSpPr>
+        <p:spPr>
+          <a:xfrm>
+            <a:off x="6080760" y="4544568"/>
+            <a:ext cx="1417319" cy="320040"/>
+          </a:xfrm>
+          <a:prstGeom prst="rect">
+            <a:avLst/>
+          </a:prstGeom>
+          <a:noFill/>
+        </p:spPr>
+        <p:txBody>
+          <a:bodyPr wrap="square" lIns="0" rIns="0" tIns="0" bIns="0" anchor="t"/>
+          <a:lstStyle/>
+          <a:p>
+            <a:pPr algn="r">
+              <a:lnSpc>
+                <a:spcPct val="110000"/>
+              </a:lnSpc>
+              <a:spcAft>
+                <a:spcPts val="0"/>
+              </a:spcAft>
+            </a:pPr>
+            <a:r>
+              <a:rPr sz="1700" b="1" i="0">
+                <a:solidFill>
+                  <a:srgbClr val="1B2A30"/>
+                </a:solidFill>
+                <a:latin typeface="Arial"/>
+              </a:rPr>
+              <a:t>-2.0 pts</a:t>
+            </a:r>
+          </a:p>
+        </p:txBody>
+      </p:sp>
+      <p:sp>
+        <p:nvSpPr>
+          <p:cNvPr id="21" name="TextBox 20"/>
+          <p:cNvSpPr txBox="1"/>
+          <p:nvPr/>
+        </p:nvSpPr>
+        <p:spPr>
+          <a:xfrm>
+            <a:off x="5623560" y="4837176"/>
+            <a:ext cx="1874519" cy="274320"/>
+          </a:xfrm>
+          <a:prstGeom prst="rect">
+            <a:avLst/>
+          </a:prstGeom>
+          <a:noFill/>
+        </p:spPr>
+        <p:txBody>
+          <a:bodyPr wrap="square" lIns="0" rIns="0" tIns="0" bIns="0" anchor="t"/>
+          <a:lstStyle/>
+          <a:p>
+            <a:pPr algn="r">
+              <a:lnSpc>
+                <a:spcPct val="110000"/>
+              </a:lnSpc>
+              <a:spcAft>
+                <a:spcPts val="0"/>
+              </a:spcAft>
+            </a:pPr>
+            <a:r>
+              <a:rPr sz="1200" b="0" i="0">
+                <a:solidFill>
+                  <a:srgbClr val="5C6A70"/>
+                </a:solidFill>
+                <a:latin typeface="Arial"/>
+              </a:rPr>
+              <a:t>-2.0 pts to +0.9 pts</a:t>
+            </a:r>
+          </a:p>
+        </p:txBody>
+      </p:sp>
+      <p:sp>
+        <p:nvSpPr>
+          <p:cNvPr id="22" name="TextBox 21"/>
+          <p:cNvSpPr txBox="1"/>
+          <p:nvPr/>
+        </p:nvSpPr>
+        <p:spPr>
+          <a:xfrm>
+            <a:off x="4617720" y="5111496"/>
+            <a:ext cx="1645920" cy="320040"/>
+          </a:xfrm>
+          <a:prstGeom prst="rect">
+            <a:avLst/>
+          </a:prstGeom>
+          <a:noFill/>
+        </p:spPr>
+        <p:txBody>
+          <a:bodyPr wrap="square" lIns="0" rIns="0" tIns="0" bIns="0" anchor="t"/>
+          <a:lstStyle/>
+          <a:p>
+            <a:pPr algn="l">
+              <a:lnSpc>
+                <a:spcPct val="110000"/>
+              </a:lnSpc>
+              <a:spcAft>
+                <a:spcPts val="0"/>
+              </a:spcAft>
+            </a:pPr>
+            <a:r>
+              <a:rPr sz="1500" b="0" i="0">
+                <a:solidFill>
+                  <a:srgbClr val="1B2A30"/>
+                </a:solidFill>
+                <a:latin typeface="Arial"/>
+              </a:rPr>
+              <a:t>Diversity index</a:t>
+            </a:r>
+          </a:p>
+        </p:txBody>
+      </p:sp>
+      <p:sp>
+        <p:nvSpPr>
+          <p:cNvPr id="23" name="TextBox 22"/>
+          <p:cNvSpPr txBox="1"/>
+          <p:nvPr/>
+        </p:nvSpPr>
+        <p:spPr>
+          <a:xfrm>
+            <a:off x="6080760" y="5111496"/>
+            <a:ext cx="1417319" cy="320040"/>
+          </a:xfrm>
+          <a:prstGeom prst="rect">
+            <a:avLst/>
+          </a:prstGeom>
+          <a:noFill/>
+        </p:spPr>
+        <p:txBody>
+          <a:bodyPr wrap="square" lIns="0" rIns="0" tIns="0" bIns="0" anchor="t"/>
+          <a:lstStyle/>
+          <a:p>
+            <a:pPr algn="r">
+              <a:lnSpc>
+                <a:spcPct val="110000"/>
+              </a:lnSpc>
+              <a:spcAft>
+                <a:spcPts val="0"/>
+              </a:spcAft>
+            </a:pPr>
+            <a:r>
+              <a:rPr sz="1700" b="1" i="0">
+                <a:solidFill>
+                  <a:srgbClr val="1B2A30"/>
+                </a:solidFill>
+                <a:latin typeface="Arial"/>
+              </a:rPr>
+              <a:t>+0.019</a:t>
+            </a:r>
+          </a:p>
+        </p:txBody>
+      </p:sp>
+      <p:sp>
+        <p:nvSpPr>
+          <p:cNvPr id="24" name="Rounded Rectangle 23"/>
+          <p:cNvSpPr/>
+          <p:nvPr/>
+        </p:nvSpPr>
+        <p:spPr>
+          <a:xfrm>
+            <a:off x="8046719" y="2240280"/>
+            <a:ext cx="3429000" cy="3383280"/>
+          </a:xfrm>
+          <a:prstGeom prst="roundRect">
+            <a:avLst>
+              <a:gd name="adj" fmla="val 8000"/>
+            </a:avLst>
+          </a:prstGeom>
+          <a:solidFill>
+            <a:srgbClr val="E9F2F2"/>
+          </a:solidFill>
+          <a:ln>
+            <a:noFill/>
+          </a:ln>
+        </p:spPr>
+        <p:txBody>
+          <a:bodyPr rtlCol="0" anchor="ctr"/>
+          <a:lstStyle/>
+          <a:p>
+            <a:pPr algn="ctr"/>
+          </a:p>
+        </p:txBody>
+      </p:sp>
+      <p:sp>
+        <p:nvSpPr>
+          <p:cNvPr id="25" name="TextBox 24"/>
+          <p:cNvSpPr txBox="1"/>
+          <p:nvPr/>
+        </p:nvSpPr>
+        <p:spPr>
+          <a:xfrm>
+            <a:off x="8321040" y="2468880"/>
+            <a:ext cx="2880360" cy="411480"/>
+          </a:xfrm>
+          <a:prstGeom prst="rect">
+            <a:avLst/>
+          </a:prstGeom>
+          <a:noFill/>
+        </p:spPr>
+        <p:txBody>
+          <a:bodyPr wrap="square" lIns="0" rIns="0" tIns="0" bIns="0" anchor="t"/>
+          <a:lstStyle/>
+          <a:p>
+            <a:pPr algn="l">
+              <a:lnSpc>
+                <a:spcPct val="110000"/>
+              </a:lnSpc>
+              <a:spcAft>
+                <a:spcPts val="0"/>
+              </a:spcAft>
+            </a:pPr>
+            <a:r>
+              <a:rPr sz="2100" b="1" i="0">
+                <a:solidFill>
+                  <a:srgbClr val="0E5E63"/>
+                </a:solidFill>
+                <a:latin typeface="Arial"/>
+              </a:rPr>
+              <a:t>Balanced</a:t>
+            </a:r>
+          </a:p>
+        </p:txBody>
+      </p:sp>
+      <p:sp>
+        <p:nvSpPr>
+          <p:cNvPr id="26" name="TextBox 25"/>
+          <p:cNvSpPr txBox="1"/>
+          <p:nvPr/>
+        </p:nvSpPr>
+        <p:spPr>
+          <a:xfrm>
+            <a:off x="8321040" y="2971800"/>
+            <a:ext cx="2880360" cy="1188720"/>
+          </a:xfrm>
+          <a:prstGeom prst="rect">
+            <a:avLst/>
+          </a:prstGeom>
+          <a:noFill/>
+        </p:spPr>
+        <p:txBody>
+          <a:bodyPr wrap="square" lIns="0" rIns="0" tIns="0" bIns="0" anchor="t"/>
+          <a:lstStyle/>
+          <a:p>
+            <a:pPr algn="l">
+              <a:lnSpc>
+                <a:spcPct val="105000"/>
+              </a:lnSpc>
+              <a:spcAft>
+                <a:spcPts val="0"/>
+              </a:spcAft>
+            </a:pPr>
+            <a:r>
+              <a:rPr sz="1400" b="0" i="0">
+                <a:solidFill>
+                  <a:srgbClr val="5C6A70"/>
+                </a:solidFill>
+                <a:latin typeface="Arial"/>
+              </a:rPr>
+              <a:t>ECOG (I6): ≤ 1 to ≤ 2</a:t>
+            </a:r>
+          </a:p>
+          <a:p>
+            <a:pPr algn="l">
+              <a:lnSpc>
+                <a:spcPct val="105000"/>
+              </a:lnSpc>
+              <a:spcAft>
+                <a:spcPts val="0"/>
+              </a:spcAft>
+            </a:pPr>
+            <a:r>
+              <a:rPr sz="1400" b="0" i="0">
+                <a:solidFill>
+                  <a:srgbClr val="5C6A70"/>
+                </a:solidFill>
+                <a:latin typeface="Arial"/>
+              </a:rPr>
+              <a:t>Drop histology rule (I1)</a:t>
+            </a:r>
+          </a:p>
+          <a:p>
+            <a:pPr algn="l">
+              <a:lnSpc>
+                <a:spcPct val="105000"/>
+              </a:lnSpc>
+              <a:spcAft>
+                <a:spcPts val="0"/>
+              </a:spcAft>
+            </a:pPr>
+            <a:r>
+              <a:rPr sz="1400" b="0" i="0">
+                <a:solidFill>
+                  <a:srgbClr val="5C6A70"/>
+                </a:solidFill>
+                <a:latin typeface="Arial"/>
+              </a:rPr>
+              <a:t>Drop CrCl (I14)</a:t>
+            </a:r>
+          </a:p>
+        </p:txBody>
+      </p:sp>
+      <p:sp>
+        <p:nvSpPr>
+          <p:cNvPr id="27" name="TextBox 26"/>
+          <p:cNvSpPr txBox="1"/>
+          <p:nvPr/>
+        </p:nvSpPr>
+        <p:spPr>
+          <a:xfrm>
+            <a:off x="8321040" y="3977639"/>
+            <a:ext cx="1645920" cy="320040"/>
+          </a:xfrm>
+          <a:prstGeom prst="rect">
+            <a:avLst/>
+          </a:prstGeom>
+          <a:noFill/>
+        </p:spPr>
+        <p:txBody>
+          <a:bodyPr wrap="square" lIns="0" rIns="0" tIns="0" bIns="0" anchor="t"/>
+          <a:lstStyle/>
+          <a:p>
+            <a:pPr algn="l">
+              <a:lnSpc>
+                <a:spcPct val="110000"/>
+              </a:lnSpc>
+              <a:spcAft>
+                <a:spcPts val="0"/>
+              </a:spcAft>
+            </a:pPr>
+            <a:r>
+              <a:rPr sz="1500" b="0" i="0">
+                <a:solidFill>
+                  <a:srgbClr val="1B2A30"/>
+                </a:solidFill>
+                <a:latin typeface="Arial"/>
+              </a:rPr>
+              <a:t>Enrollment speed</a:t>
+            </a:r>
+          </a:p>
+        </p:txBody>
+      </p:sp>
+      <p:sp>
+        <p:nvSpPr>
+          <p:cNvPr id="28" name="TextBox 27"/>
+          <p:cNvSpPr txBox="1"/>
+          <p:nvPr/>
+        </p:nvSpPr>
+        <p:spPr>
+          <a:xfrm>
+            <a:off x="9784080" y="3977639"/>
+            <a:ext cx="1417319" cy="320040"/>
+          </a:xfrm>
+          <a:prstGeom prst="rect">
+            <a:avLst/>
+          </a:prstGeom>
+          <a:noFill/>
+        </p:spPr>
+        <p:txBody>
+          <a:bodyPr wrap="square" lIns="0" rIns="0" tIns="0" bIns="0" anchor="t"/>
+          <a:lstStyle/>
+          <a:p>
+            <a:pPr algn="r">
+              <a:lnSpc>
+                <a:spcPct val="110000"/>
+              </a:lnSpc>
+              <a:spcAft>
+                <a:spcPts val="0"/>
+              </a:spcAft>
+            </a:pPr>
+            <a:r>
+              <a:rPr sz="1700" b="1" i="0">
+                <a:solidFill>
+                  <a:srgbClr val="1B2A30"/>
+                </a:solidFill>
+                <a:latin typeface="Arial"/>
+              </a:rPr>
+              <a:t>+95%</a:t>
+            </a:r>
+          </a:p>
+        </p:txBody>
+      </p:sp>
+      <p:sp>
+        <p:nvSpPr>
+          <p:cNvPr id="29" name="TextBox 28"/>
+          <p:cNvSpPr txBox="1"/>
+          <p:nvPr/>
+        </p:nvSpPr>
+        <p:spPr>
+          <a:xfrm>
+            <a:off x="9326880" y="4270248"/>
+            <a:ext cx="1874519" cy="274320"/>
+          </a:xfrm>
+          <a:prstGeom prst="rect">
+            <a:avLst/>
+          </a:prstGeom>
+          <a:noFill/>
+        </p:spPr>
+        <p:txBody>
+          <a:bodyPr wrap="square" lIns="0" rIns="0" tIns="0" bIns="0" anchor="t"/>
+          <a:lstStyle/>
+          <a:p>
+            <a:pPr algn="r">
+              <a:lnSpc>
+                <a:spcPct val="110000"/>
+              </a:lnSpc>
+              <a:spcAft>
+                <a:spcPts val="0"/>
+              </a:spcAft>
+            </a:pPr>
+            <a:r>
+              <a:rPr sz="1200" b="0" i="0">
+                <a:solidFill>
+                  <a:srgbClr val="5C6A70"/>
+                </a:solidFill>
+                <a:latin typeface="Arial"/>
+              </a:rPr>
+              <a:t>+90% to +128%</a:t>
+            </a:r>
+          </a:p>
+        </p:txBody>
+      </p:sp>
+      <p:sp>
+        <p:nvSpPr>
+          <p:cNvPr id="30" name="TextBox 29"/>
+          <p:cNvSpPr txBox="1"/>
+          <p:nvPr/>
+        </p:nvSpPr>
+        <p:spPr>
+          <a:xfrm>
+            <a:off x="8321040" y="4544568"/>
+            <a:ext cx="1645920" cy="320040"/>
+          </a:xfrm>
+          <a:prstGeom prst="rect">
+            <a:avLst/>
+          </a:prstGeom>
+          <a:noFill/>
+        </p:spPr>
+        <p:txBody>
+          <a:bodyPr wrap="square" lIns="0" rIns="0" tIns="0" bIns="0" anchor="t"/>
+          <a:lstStyle/>
+          <a:p>
+            <a:pPr algn="l">
+              <a:lnSpc>
+                <a:spcPct val="110000"/>
+              </a:lnSpc>
+              <a:spcAft>
+                <a:spcPts val="0"/>
+              </a:spcAft>
+            </a:pPr>
+            <a:r>
+              <a:rPr sz="1500" b="0" i="0">
+                <a:solidFill>
+                  <a:srgbClr val="1B2A30"/>
+                </a:solidFill>
+                <a:latin typeface="Arial"/>
+              </a:rPr>
+              <a:t>Dropout</a:t>
+            </a:r>
+          </a:p>
+        </p:txBody>
+      </p:sp>
+      <p:sp>
+        <p:nvSpPr>
+          <p:cNvPr id="31" name="TextBox 30"/>
+          <p:cNvSpPr txBox="1"/>
+          <p:nvPr/>
+        </p:nvSpPr>
+        <p:spPr>
+          <a:xfrm>
+            <a:off x="9784080" y="4544568"/>
+            <a:ext cx="1417319" cy="320040"/>
+          </a:xfrm>
+          <a:prstGeom prst="rect">
+            <a:avLst/>
+          </a:prstGeom>
+          <a:noFill/>
+        </p:spPr>
+        <p:txBody>
+          <a:bodyPr wrap="square" lIns="0" rIns="0" tIns="0" bIns="0" anchor="t"/>
+          <a:lstStyle/>
+          <a:p>
+            <a:pPr algn="r">
+              <a:lnSpc>
+                <a:spcPct val="110000"/>
+              </a:lnSpc>
+              <a:spcAft>
+                <a:spcPts val="0"/>
+              </a:spcAft>
+            </a:pPr>
+            <a:r>
+              <a:rPr sz="1700" b="1" i="0">
+                <a:solidFill>
+                  <a:srgbClr val="1B2A30"/>
+                </a:solidFill>
+                <a:latin typeface="Arial"/>
+              </a:rPr>
+              <a:t>+3.6 pts</a:t>
+            </a:r>
+          </a:p>
+        </p:txBody>
+      </p:sp>
+      <p:sp>
+        <p:nvSpPr>
+          <p:cNvPr id="32" name="TextBox 31"/>
+          <p:cNvSpPr txBox="1"/>
+          <p:nvPr/>
+        </p:nvSpPr>
+        <p:spPr>
+          <a:xfrm>
+            <a:off x="9326880" y="4837176"/>
+            <a:ext cx="1874519" cy="274320"/>
+          </a:xfrm>
+          <a:prstGeom prst="rect">
+            <a:avLst/>
+          </a:prstGeom>
+          <a:noFill/>
+        </p:spPr>
+        <p:txBody>
+          <a:bodyPr wrap="square" lIns="0" rIns="0" tIns="0" bIns="0" anchor="t"/>
+          <a:lstStyle/>
+          <a:p>
+            <a:pPr algn="r">
+              <a:lnSpc>
+                <a:spcPct val="110000"/>
+              </a:lnSpc>
+              <a:spcAft>
+                <a:spcPts val="0"/>
+              </a:spcAft>
+            </a:pPr>
+            <a:r>
+              <a:rPr sz="1200" b="0" i="0">
+                <a:solidFill>
+                  <a:srgbClr val="5C6A70"/>
+                </a:solidFill>
+                <a:latin typeface="Arial"/>
+              </a:rPr>
+              <a:t>+3.6 pts to +5.0 pts</a:t>
+            </a:r>
+          </a:p>
+        </p:txBody>
+      </p:sp>
+      <p:sp>
+        <p:nvSpPr>
+          <p:cNvPr id="33" name="TextBox 32"/>
+          <p:cNvSpPr txBox="1"/>
+          <p:nvPr/>
+        </p:nvSpPr>
+        <p:spPr>
+          <a:xfrm>
+            <a:off x="8321040" y="5111496"/>
+            <a:ext cx="1645920" cy="320040"/>
+          </a:xfrm>
+          <a:prstGeom prst="rect">
+            <a:avLst/>
+          </a:prstGeom>
+          <a:noFill/>
+        </p:spPr>
+        <p:txBody>
+          <a:bodyPr wrap="square" lIns="0" rIns="0" tIns="0" bIns="0" anchor="t"/>
+          <a:lstStyle/>
+          <a:p>
+            <a:pPr algn="l">
+              <a:lnSpc>
+                <a:spcPct val="110000"/>
+              </a:lnSpc>
+              <a:spcAft>
+                <a:spcPts val="0"/>
+              </a:spcAft>
+            </a:pPr>
+            <a:r>
+              <a:rPr sz="1500" b="0" i="0">
+                <a:solidFill>
+                  <a:srgbClr val="1B2A30"/>
+                </a:solidFill>
+                <a:latin typeface="Arial"/>
+              </a:rPr>
+              <a:t>Diversity index</a:t>
+            </a:r>
+          </a:p>
+        </p:txBody>
+      </p:sp>
+      <p:sp>
+        <p:nvSpPr>
+          <p:cNvPr id="34" name="TextBox 33"/>
+          <p:cNvSpPr txBox="1"/>
+          <p:nvPr/>
+        </p:nvSpPr>
+        <p:spPr>
+          <a:xfrm>
+            <a:off x="9784080" y="5111496"/>
+            <a:ext cx="1417319" cy="320040"/>
+          </a:xfrm>
+          <a:prstGeom prst="rect">
+            <a:avLst/>
+          </a:prstGeom>
+          <a:noFill/>
+        </p:spPr>
+        <p:txBody>
+          <a:bodyPr wrap="square" lIns="0" rIns="0" tIns="0" bIns="0" anchor="t"/>
+          <a:lstStyle/>
+          <a:p>
+            <a:pPr algn="r">
+              <a:lnSpc>
+                <a:spcPct val="110000"/>
+              </a:lnSpc>
+              <a:spcAft>
+                <a:spcPts val="0"/>
+              </a:spcAft>
+            </a:pPr>
+            <a:r>
+              <a:rPr sz="1700" b="1" i="0">
+                <a:solidFill>
+                  <a:srgbClr val="1B2A30"/>
+                </a:solidFill>
+                <a:latin typeface="Arial"/>
+              </a:rPr>
+              <a:t>+0.037</a:t>
+            </a:r>
+          </a:p>
+        </p:txBody>
+      </p:sp>
+      <p:sp>
+        <p:nvSpPr>
+          <p:cNvPr id="35" name="TextBox 34"/>
+          <p:cNvSpPr txBox="1"/>
+          <p:nvPr/>
+        </p:nvSpPr>
+        <p:spPr>
+          <a:xfrm>
+            <a:off x="640080" y="5852160"/>
+            <a:ext cx="10911535" cy="365760"/>
+          </a:xfrm>
+          <a:prstGeom prst="rect">
+            <a:avLst/>
+          </a:prstGeom>
+          <a:noFill/>
+        </p:spPr>
+        <p:txBody>
+          <a:bodyPr wrap="square" lIns="0" rIns="0" tIns="0" bIns="0" anchor="t"/>
+          <a:lstStyle/>
+          <a:p>
+            <a:pPr algn="l">
+              <a:lnSpc>
+                <a:spcPct val="110000"/>
+              </a:lnSpc>
+              <a:spcAft>
+                <a:spcPts val="0"/>
+              </a:spcAft>
+            </a:pPr>
+            <a:r>
+              <a:rPr sz="1400" b="0" i="0">
+                <a:solidFill>
+                  <a:srgbClr val="5C6A70"/>
+                </a:solidFill>
+                <a:latin typeface="Arial"/>
+              </a:rPr>
+              <a:t>Ranges: 5 cohort seeds. No dollar value yet (no amendment labels). Authors lock rules that define the trial's population</a:t>
+            </a:r>
+          </a:p>
+        </p:txBody>
+      </p:sp>
+      <p:sp>
+        <p:nvSpPr>
+          <p:cNvPr id="36" name="TextBox 35"/>
+          <p:cNvSpPr txBox="1"/>
+          <p:nvPr/>
+        </p:nvSpPr>
+        <p:spPr>
+          <a:xfrm>
+            <a:off x="640080" y="457200"/>
+            <a:ext cx="8229600" cy="320040"/>
+          </a:xfrm>
+          <a:prstGeom prst="rect">
+            <a:avLst/>
+          </a:prstGeom>
+          <a:noFill/>
+        </p:spPr>
+        <p:txBody>
+          <a:bodyPr wrap="square" lIns="0" rIns="0" tIns="0" bIns="0" anchor="t"/>
+          <a:lstStyle/>
+          <a:p>
+            <a:pPr algn="l">
+              <a:lnSpc>
+                <a:spcPct val="110000"/>
+              </a:lnSpc>
+              <a:spcAft>
+                <a:spcPts val="0"/>
+              </a:spcAft>
+            </a:pPr>
+            <a:r>
+              <a:rPr sz="1300" b="1" i="0">
+                <a:solidFill>
+                  <a:srgbClr val="2E8A8F"/>
+                </a:solidFill>
+                <a:latin typeface="Arial"/>
+              </a:rPr>
+              <a:t>OPTIMIZER</a:t>
+            </a:r>
+          </a:p>
+        </p:txBody>
+      </p:sp>
+      <p:sp>
+        <p:nvSpPr>
+          <p:cNvPr id="37" name="Title"/>
+          <p:cNvSpPr txBox="1"/>
+          <p:nvPr/>
+        </p:nvSpPr>
+        <p:spPr>
+          <a:xfrm>
+            <a:off x="640080" y="868680"/>
+            <a:ext cx="10911535" cy="1143000"/>
+          </a:xfrm>
+          <a:prstGeom prst="rect">
+            <a:avLst/>
+          </a:prstGeom>
+          <a:noFill/>
+        </p:spPr>
+        <p:txBody>
+          <a:bodyPr wrap="square" lIns="0" rIns="0" tIns="0" bIns="0" anchor="t"/>
+          <a:lstStyle/>
+          <a:p>
+            <a:pPr algn="l">
+              <a:lnSpc>
+                <a:spcPct val="105000"/>
+              </a:lnSpc>
+              <a:spcAft>
+                <a:spcPts val="0"/>
+              </a:spcAft>
+            </a:pPr>
+            <a:r>
+              <a:rPr sz="3000" b="1" i="0">
+                <a:solidFill>
+                  <a:srgbClr val="1B2A30"/>
+                </a:solidFill>
+                <a:latin typeface="Arial"/>
+              </a:rPr>
+              <a:t>The optimizer proposes three trade-offs with ranges; the author decides which, if any</a:t>
+            </a:r>
+          </a:p>
+        </p:txBody>
+      </p:sp>
+      <p:sp>
+        <p:nvSpPr>
+          <p:cNvPr id="38" name="TextBox 37"/>
+          <p:cNvSpPr txBox="1"/>
+          <p:nvPr/>
+        </p:nvSpPr>
+        <p:spPr>
+          <a:xfrm>
+            <a:off x="10637215" y="6400800"/>
+            <a:ext cx="914400" cy="274320"/>
+          </a:xfrm>
+          <a:prstGeom prst="rect">
+            <a:avLst/>
+          </a:prstGeom>
+          <a:noFill/>
+        </p:spPr>
+        <p:txBody>
+          <a:bodyPr wrap="square" lIns="0" rIns="0" tIns="0" bIns="0" anchor="t"/>
+          <a:lstStyle/>
+          <a:p>
+            <a:pPr algn="r">
+              <a:lnSpc>
+                <a:spcPct val="110000"/>
+              </a:lnSpc>
+              <a:spcAft>
+                <a:spcPts val="0"/>
+              </a:spcAft>
+            </a:pPr>
+            <a:r>
+              <a:rPr sz="1100" b="0" i="0">
+                <a:solidFill>
+                  <a:srgbClr val="A9B4B8"/>
+                </a:solidFill>
+                <a:latin typeface="Arial"/>
+              </a:rPr>
+              <a:t>7 / 12</a:t>
+            </a:r>
+          </a:p>
+        </p:txBody>
+      </p:sp>
+      <p:sp>
+        <p:nvSpPr>
+          <p:cNvPr id="39" name="TextBox 38"/>
+          <p:cNvSpPr txBox="1"/>
+          <p:nvPr/>
+        </p:nvSpPr>
+        <p:spPr>
+          <a:xfrm>
+            <a:off x="640080" y="6400800"/>
+            <a:ext cx="8686800" cy="274320"/>
+          </a:xfrm>
+          <a:prstGeom prst="rect">
+            <a:avLst/>
+          </a:prstGeom>
+          <a:noFill/>
+        </p:spPr>
+        <p:txBody>
+          <a:bodyPr wrap="square" lIns="0" rIns="0" tIns="0" bIns="0" anchor="t"/>
+          <a:lstStyle/>
+          <a:p>
+            <a:pPr algn="l">
+              <a:lnSpc>
+                <a:spcPct val="110000"/>
+              </a:lnSpc>
+              <a:spcAft>
+                <a:spcPts val="0"/>
+              </a:spcAft>
+            </a:pPr>
+            <a:r>
+              <a:rPr sz="1000" b="0" i="0">
+                <a:solidFill>
+                  <a:srgbClr val="A9B4B8"/>
+                </a:solidFill>
+                <a:latin typeface="Arial"/>
+              </a:rPr>
+              <a:t>Sources: docs/demo_results/NCT03232892_optimize.json</a:t>
             </a:r>
           </a:p>
         </p:txBody>
@@ -11025,151 +12274,57 @@
         <p:nvPr/>
       </p:nvGrpSpPr>
       <p:grpSpPr/>
-      <p:sp>
-        <p:nvSpPr>
-          <p:cNvPr id="2" name="Rounded Rectangle 1"/>
-          <p:cNvSpPr/>
-          <p:nvPr/>
-        </p:nvSpPr>
-        <p:spPr>
-          <a:xfrm>
-            <a:off x="640080" y="2240280"/>
-            <a:ext cx="5943600" cy="3108960"/>
-          </a:xfrm>
-          <a:prstGeom prst="roundRect">
-            <a:avLst>
-              <a:gd name="adj" fmla="val 4000"/>
-            </a:avLst>
-          </a:prstGeom>
-          <a:noFill/>
-          <a:ln w="15875">
-            <a:solidFill>
-              <a:srgbClr val="C8492F"/>
-            </a:solidFill>
-          </a:ln>
-        </p:spPr>
-        <p:txBody>
-          <a:bodyPr rtlCol="0" anchor="ctr"/>
-          <a:lstStyle/>
-          <a:p>
-            <a:pPr algn="ctr"/>
-          </a:p>
-        </p:txBody>
-      </p:sp>
-      <p:sp>
-        <p:nvSpPr>
-          <p:cNvPr id="3" name="TextBox 2"/>
-          <p:cNvSpPr txBox="1"/>
-          <p:nvPr/>
-        </p:nvSpPr>
-        <p:spPr>
-          <a:xfrm>
-            <a:off x="914400" y="2240280"/>
-            <a:ext cx="5394960" cy="3108960"/>
-          </a:xfrm>
-          <a:prstGeom prst="rect">
-            <a:avLst/>
-          </a:prstGeom>
-          <a:noFill/>
-        </p:spPr>
-        <p:txBody>
-          <a:bodyPr wrap="square" lIns="0" rIns="0" tIns="0" bIns="0" anchor="ctr"/>
-          <a:lstStyle/>
-          <a:p>
-            <a:pPr algn="ctr">
-              <a:lnSpc>
-                <a:spcPct val="110000"/>
-              </a:lnSpc>
-              <a:spcAft>
-                <a:spcPts val="0"/>
-              </a:spcAft>
-            </a:pPr>
-            <a:r>
-              <a:rPr sz="1800" b="0" i="0">
-                <a:solidFill>
-                  <a:srgbClr val="C8492F"/>
-                </a:solidFill>
-                <a:latin typeface="Arial"/>
-              </a:rPr>
-              <a:t>[TBD: AUC chart from docs/metrics.json]</a:t>
-            </a:r>
-          </a:p>
-        </p:txBody>
-      </p:sp>
-      <p:sp>
-        <p:nvSpPr>
-          <p:cNvPr id="4" name="Rounded Rectangle 3"/>
-          <p:cNvSpPr/>
-          <p:nvPr/>
-        </p:nvSpPr>
-        <p:spPr>
-          <a:xfrm>
-            <a:off x="6812280" y="2240280"/>
-            <a:ext cx="4739335" cy="3108960"/>
-          </a:xfrm>
-          <a:prstGeom prst="roundRect">
-            <a:avLst>
-              <a:gd name="adj" fmla="val 4000"/>
-            </a:avLst>
-          </a:prstGeom>
-          <a:noFill/>
-          <a:ln w="15875">
-            <a:solidFill>
-              <a:srgbClr val="C8492F"/>
-            </a:solidFill>
-          </a:ln>
-        </p:spPr>
-        <p:txBody>
-          <a:bodyPr rtlCol="0" anchor="ctr"/>
-          <a:lstStyle/>
-          <a:p>
-            <a:pPr algn="ctr"/>
-          </a:p>
-        </p:txBody>
-      </p:sp>
-      <p:sp>
-        <p:nvSpPr>
-          <p:cNvPr id="5" name="TextBox 4"/>
-          <p:cNvSpPr txBox="1"/>
-          <p:nvPr/>
-        </p:nvSpPr>
-        <p:spPr>
-          <a:xfrm>
-            <a:off x="7086600" y="2240280"/>
-            <a:ext cx="4190695" cy="3108960"/>
-          </a:xfrm>
-          <a:prstGeom prst="rect">
-            <a:avLst/>
-          </a:prstGeom>
-          <a:noFill/>
-        </p:spPr>
-        <p:txBody>
-          <a:bodyPr wrap="square" lIns="0" rIns="0" tIns="0" bIns="0" anchor="ctr"/>
-          <a:lstStyle/>
-          <a:p>
-            <a:pPr algn="ctr">
-              <a:lnSpc>
-                <a:spcPct val="110000"/>
-              </a:lnSpc>
-              <a:spcAft>
-                <a:spcPts val="0"/>
-              </a:spcAft>
-            </a:pPr>
-            <a:r>
-              <a:rPr sz="1800" b="0" i="0">
-                <a:solidFill>
-                  <a:srgbClr val="C8492F"/>
-                </a:solidFill>
-                <a:latin typeface="Arial"/>
-              </a:rPr>
-              <a:t>[TBD: hit-rate chart from docs/metrics.json]</a:t>
-            </a:r>
-          </a:p>
-        </p:txBody>
-      </p:sp>
-      <p:sp>
-        <p:nvSpPr>
-          <p:cNvPr id="6" name="TextBox 5"/>
+      <p:pic>
+        <p:nvPicPr>
+          <p:cNvPr id="2" name="Picture 1" descr="auc_vs_baseline.png"/>
+          <p:cNvPicPr>
+            <a:picLocks noChangeAspect="1"/>
+          </p:cNvPicPr>
+          <p:nvPr/>
+        </p:nvPicPr>
+        <p:blipFill>
+          <a:blip r:embed="rId2"/>
+          <a:stretch>
+            <a:fillRect/>
+          </a:stretch>
+        </p:blipFill>
+        <p:spPr>
+          <a:xfrm>
+            <a:off x="640080" y="2190041"/>
+            <a:ext cx="5943600" cy="2660797"/>
+          </a:xfrm>
+          <a:prstGeom prst="rect">
+            <a:avLst/>
+          </a:prstGeom>
+        </p:spPr>
+      </p:pic>
+      <p:pic>
+        <p:nvPicPr>
+          <p:cNvPr id="3" name="Picture 2" descr="auc_gain.png"/>
+          <p:cNvPicPr>
+            <a:picLocks noChangeAspect="1"/>
+          </p:cNvPicPr>
+          <p:nvPr/>
+        </p:nvPicPr>
+        <p:blipFill>
+          <a:blip r:embed="rId3"/>
+          <a:stretch>
+            <a:fillRect/>
+          </a:stretch>
+        </p:blipFill>
+        <p:spPr>
+          <a:xfrm>
+            <a:off x="6812280" y="2200196"/>
+            <a:ext cx="4739335" cy="2640486"/>
+          </a:xfrm>
+          <a:prstGeom prst="rect">
+            <a:avLst/>
+          </a:prstGeom>
+        </p:spPr>
+      </p:pic>
+      <p:sp>
+        <p:nvSpPr>
+          <p:cNvPr id="4" name="TextBox 3"/>
           <p:cNvSpPr txBox="1"/>
           <p:nvPr/>
         </p:nvSpPr>
@@ -11208,7 +12363,7 @@
                 </a:solidFill>
                 <a:latin typeface="Arial"/>
               </a:rPr>
-              <a:t>Accrual failure: AUC [TBD: metrics.json accrual_fail AUC] (95% CI ) vs baseline [TBD: metrics.json accrual_fail AUC baseline] ()</a:t>
+              <a:t>Accrual failure: AUC 0.70 (95% CI 0.62–0.77) vs logistic baseline 0.66 (0.59–0.72)</a:t>
             </a:r>
           </a:p>
           <a:p>
@@ -11233,7 +12388,7 @@
                 </a:solidFill>
                 <a:latin typeface="Arial"/>
               </a:rPr>
-              <a:t>Hit rate: [TBD: metrics.json hit_rate] (random [TBD: metrics.json hit_rate random], largest exclusion [TBD: metrics.json hit_rate marginal])</a:t>
+              <a:t>Paired AUC gain +0.04 (95% CI −0.04 to +0.12): the interval includes zero</a:t>
             </a:r>
           </a:p>
           <a:p>
@@ -11258,7 +12413,87 @@
                 </a:solidFill>
                 <a:latin typeface="Arial"/>
               </a:rPr>
-              <a:t>Simulation ablation: [TBD: metrics.json ablation diff]</a:t>
+              <a:t>Brier 0.083 vs 0.086 for predicting the base rate; hit rate and simulation benefit not computable yet</a:t>
+            </a:r>
+          </a:p>
+        </p:txBody>
+      </p:sp>
+      <p:sp>
+        <p:nvSpPr>
+          <p:cNvPr id="5" name="TextBox 4"/>
+          <p:cNvSpPr txBox="1"/>
+          <p:nvPr/>
+        </p:nvSpPr>
+        <p:spPr>
+          <a:xfrm>
+            <a:off x="640080" y="457200"/>
+            <a:ext cx="8229600" cy="320040"/>
+          </a:xfrm>
+          <a:prstGeom prst="rect">
+            <a:avLst/>
+          </a:prstGeom>
+          <a:noFill/>
+        </p:spPr>
+        <p:txBody>
+          <a:bodyPr wrap="square" lIns="0" rIns="0" tIns="0" bIns="0" anchor="t"/>
+          <a:lstStyle/>
+          <a:p>
+            <a:pPr algn="l">
+              <a:lnSpc>
+                <a:spcPct val="110000"/>
+              </a:lnSpc>
+              <a:spcAft>
+                <a:spcPts val="0"/>
+              </a:spcAft>
+            </a:pPr>
+            <a:r>
+              <a:rPr sz="1300" b="1" i="0">
+                <a:solidFill>
+                  <a:srgbClr val="2E8A8F"/>
+                </a:solidFill>
+                <a:latin typeface="Arial"/>
+              </a:rPr>
+              <a:t>VALIDATION ON TRIALS THE MODEL NEVER SAW</a:t>
+            </a:r>
+          </a:p>
+        </p:txBody>
+      </p:sp>
+      <p:sp>
+        <p:nvSpPr>
+          <p:cNvPr id="6" name="Title"/>
+          <p:cNvSpPr txBox="1"/>
+          <p:nvPr/>
+        </p:nvSpPr>
+        <p:spPr>
+          <a:xfrm>
+            <a:off x="640080" y="868680"/>
+            <a:ext cx="10911535" cy="1143000"/>
+          </a:xfrm>
+          <a:prstGeom prst="rect">
+            <a:avLst/>
+          </a:prstGeom>
+          <a:noFill/>
+        </p:spPr>
+        <p:txBody>
+          <a:bodyPr wrap="square" lIns="0" rIns="0" tIns="0" bIns="0" anchor="t"/>
+          <a:lstStyle/>
+          <a:p>
+            <a:pPr algn="l">
+              <a:lnSpc>
+                <a:spcPct val="105000"/>
+              </a:lnSpc>
+              <a:spcAft>
+                <a:spcPts val="0"/>
+              </a:spcAft>
+            </a:pPr>
+            <a:r>
+              <a:rPr sz="3000" b="1" i="0">
+                <a:solidFill>
+                  <a:srgbClr val="1B2A30"/>
+                </a:solidFill>
+                <a:latin typeface="Arial"/>
+              </a:rPr>
+              <a:t>On 359 unseen trials, accrual-failure AUC is 0.70: above chance, not yet shown to beat a simple baseline</a:t>
             </a:r>
           </a:p>
         </p:txBody>
@@ -11271,86 +12506,6 @@
         </p:nvSpPr>
         <p:spPr>
           <a:xfrm>
-            <a:off x="640080" y="457200"/>
-            <a:ext cx="8229600" cy="320040"/>
-          </a:xfrm>
-          <a:prstGeom prst="rect">
-            <a:avLst/>
-          </a:prstGeom>
-          <a:noFill/>
-        </p:spPr>
-        <p:txBody>
-          <a:bodyPr wrap="square" lIns="0" rIns="0" tIns="0" bIns="0" anchor="t"/>
-          <a:lstStyle/>
-          <a:p>
-            <a:pPr algn="l">
-              <a:lnSpc>
-                <a:spcPct val="110000"/>
-              </a:lnSpc>
-              <a:spcAft>
-                <a:spcPts val="0"/>
-              </a:spcAft>
-            </a:pPr>
-            <a:r>
-              <a:rPr sz="1300" b="1" i="0">
-                <a:solidFill>
-                  <a:srgbClr val="2E8A8F"/>
-                </a:solidFill>
-                <a:latin typeface="Arial"/>
-              </a:rPr>
-              <a:t>VALIDATION ON TRIALS THE MODEL NEVER SAW</a:t>
-            </a:r>
-          </a:p>
-        </p:txBody>
-      </p:sp>
-      <p:sp>
-        <p:nvSpPr>
-          <p:cNvPr id="8" name="Title"/>
-          <p:cNvSpPr txBox="1"/>
-          <p:nvPr/>
-        </p:nvSpPr>
-        <p:spPr>
-          <a:xfrm>
-            <a:off x="640080" y="868680"/>
-            <a:ext cx="10911535" cy="1143000"/>
-          </a:xfrm>
-          <a:prstGeom prst="rect">
-            <a:avLst/>
-          </a:prstGeom>
-          <a:noFill/>
-        </p:spPr>
-        <p:txBody>
-          <a:bodyPr wrap="square" lIns="0" rIns="0" tIns="0" bIns="0" anchor="t"/>
-          <a:lstStyle/>
-          <a:p>
-            <a:pPr algn="l">
-              <a:lnSpc>
-                <a:spcPct val="105000"/>
-              </a:lnSpc>
-              <a:spcAft>
-                <a:spcPts val="0"/>
-              </a:spcAft>
-            </a:pPr>
-            <a:r>
-              <a:rPr sz="3000" b="1" i="0">
-                <a:solidFill>
-                  <a:srgbClr val="1B2A30"/>
-                </a:solidFill>
-                <a:latin typeface="Arial"/>
-              </a:rPr>
-              <a:t>On unseen trials, Clinova's accrual-failure AUC is [TBD: metrics.json accrual_fail AUC] vs [TBD: metrics.json accrual_fail AUC baseline] for a baseline</a:t>
-            </a:r>
-          </a:p>
-        </p:txBody>
-      </p:sp>
-      <p:sp>
-        <p:nvSpPr>
-          <p:cNvPr id="9" name="TextBox 8"/>
-          <p:cNvSpPr txBox="1"/>
-          <p:nvPr/>
-        </p:nvSpPr>
-        <p:spPr>
-          <a:xfrm>
             <a:off x="10637215" y="6400800"/>
             <a:ext cx="914400" cy="274320"/>
           </a:xfrm>
@@ -11385,7 +12540,7 @@
       </p:sp>
       <p:sp>
         <p:nvSpPr>
-          <p:cNvPr id="10" name="TextBox 9"/>
+          <p:cNvPr id="8" name="TextBox 7"/>
           <p:cNvSpPr txBox="1"/>
           <p:nvPr/>
         </p:nvSpPr>
@@ -11418,47 +12573,7 @@
                 </a:solidFill>
                 <a:latin typeface="Arial"/>
               </a:rPr>
-              <a:t>Sources: docs/metrics.json</a:t>
-            </a:r>
-          </a:p>
-        </p:txBody>
-      </p:sp>
-      <p:sp>
-        <p:nvSpPr>
-          <p:cNvPr id="11" name="Rounded Rectangle 10"/>
-          <p:cNvSpPr/>
-          <p:nvPr/>
-        </p:nvSpPr>
-        <p:spPr>
-          <a:xfrm>
-            <a:off x="8534095" y="384048"/>
-            <a:ext cx="3017520" cy="384048"/>
-          </a:xfrm>
-          <a:prstGeom prst="roundRect">
-            <a:avLst>
-              <a:gd name="adj" fmla="val 30000"/>
-            </a:avLst>
-          </a:prstGeom>
-          <a:solidFill>
-            <a:srgbClr val="C8492F"/>
-          </a:solidFill>
-          <a:ln>
-            <a:noFill/>
-          </a:ln>
-        </p:spPr>
-        <p:txBody>
-          <a:bodyPr rtlCol="0" anchor="ctr" tIns="0" bIns="0"/>
-          <a:lstStyle/>
-          <a:p>
-            <a:pPr algn="ctr"/>
-            <a:r>
-              <a:rPr sz="1200" b="1">
-                <a:solidFill>
-                  <a:srgbClr val="FFFFFF"/>
-                </a:solidFill>
-                <a:latin typeface="Arial"/>
-              </a:rPr>
-              <a:t>DRAFT: placeholder numbers</a:t>
+              <a:t>Sources: docs/metrics.json, docs/metrics_detail.json</a:t>
             </a:r>
           </a:p>
         </p:txBody>

</xml_diff>

<commit_message>
T42: final deck from gate/3 main: T32 screenshots, all 12 renders checked, PDF
</commit_message>
<xml_diff>
--- a/docs/deck/clinova.pptx
+++ b/docs/deck/clinova.pptx
@@ -933,7 +933,7 @@
           <a:lstStyle/>
           <a:p>
             <a:r>
-              <a:t>Five steps. Read: Gemini turns eligibility rules and the visit schedule into code-checkable logic. Simulate: a virtual NSCLC cohort is screened in code, then persona agents decide whether to enroll and when they would drop out. Calibrate: LightGBM trained on real ClinicalTrials.gov trials gives calibrated risk, explained by SHAP. Optimize: test edits such as relaxing a criterion or cutting a visit, with ranges and a dollar value. Learn: every prediction is logged and scored when the trial ends. Source: docs/ARCHITECTURE.md section 1.</a:t>
+              <a:t>Five steps. Read: Gemini turns eligibility rules and the visit schedule into code-checkable logic. Simulate: a virtual NSCLC cohort is screened in code, then persona agents decide whether to enroll and when they would drop out. Calibrate: LightGBM trained on real ClinicalTrials.gov trials gives calibrated risk, explained by SHAP. Optimize: test edits such as relaxing a criterion or cutting a visit, with ranges across cohort seeds. Learn: every prediction is logged and scored when the trial ends. Source: docs/ARCHITECTURE.md section 1.</a:t>
             </a:r>
           </a:p>
         </p:txBody>
@@ -1073,7 +1073,7 @@
           <a:lstStyle/>
           <a:p>
             <a:r>
-              <a:t>This is the results screen of the running app. Left, the funnel: virtual patients screened, excluded by each criterion, enrolled and completing, with the biggest exclusion highlighted. Middle, risk: probabilities of accrual failure and enrollment shortfall, each with a range, a confidence badge and the top drivers in plain words. Right, three fixes the author can accept or reject. Everything else sits behind tabs: validation, replay, community pulse and the audit log. Screenshot: docs/screens/03-results.png.</a:t>
+              <a:t>This is the running app on the demo trial. Left, the funnel: virtual patients screened against each criterion in protocol order, with Clinova's top flag highlighted. Right, risk: each target's probability with a range, its rank among held-out test trials and the drivers in plain words. Weak evidence is labelled "not validated" or "no model yet". Below sit flags, the reveal and three fixes; tabs hold validation, replay and the audit log. Screenshot: docs/screens/03-funnel-risk.png.</a:t>
             </a:r>
           </a:p>
         </p:txBody>
@@ -4305,8 +4305,8 @@
         </p:nvSpPr>
         <p:spPr>
           <a:xfrm>
-            <a:off x="640080" y="1600200"/>
-            <a:ext cx="6035040" cy="914400"/>
+            <a:off x="640080" y="1508760"/>
+            <a:ext cx="6035040" cy="1097280"/>
           </a:xfrm>
           <a:prstGeom prst="rect">
             <a:avLst/>
@@ -4466,7 +4466,7 @@
         <p:spPr>
           <a:xfrm>
             <a:off x="6766560" y="1554480"/>
-            <a:ext cx="4846320" cy="3657600"/>
+            <a:ext cx="4846320" cy="3063240"/>
           </a:xfrm>
           <a:prstGeom prst="roundRect">
             <a:avLst>
@@ -4505,7 +4505,7 @@
         <p:spPr>
           <a:xfrm>
             <a:off x="6812280" y="1600200"/>
-            <a:ext cx="4754880" cy="3566160"/>
+            <a:ext cx="4754880" cy="2971800"/>
           </a:xfrm>
           <a:prstGeom prst="rect">
             <a:avLst/>
@@ -7095,7 +7095,7 @@
                 </a:solidFill>
                 <a:latin typeface="Arial"/>
               </a:rPr>
-              <a:t>Amendments are public</a:t>
+              <a:t>History is public</a:t>
             </a:r>
           </a:p>
         </p:txBody>
@@ -8323,7 +8323,7 @@
                 </a:solidFill>
                 <a:latin typeface="Arial"/>
               </a:rPr>
-              <a:t>Test edits; trade-offs with ranges and dollars</a:t>
+              <a:t>Test edits; see trade-offs with ranges</a:t>
             </a:r>
           </a:p>
         </p:txBody>
@@ -9286,7 +9286,7 @@
                 </a:solidFill>
                 <a:latin typeface="Arial"/>
               </a:rPr>
-              <a:t>Risk: probability with a range, a confidence badge and top drivers in plain words</a:t>
+              <a:t>Risk: probability with a range, its rank among test trials and plain-word drivers</a:t>
             </a:r>
           </a:p>
           <a:p>
@@ -9311,7 +9311,7 @@
                 </a:solidFill>
                 <a:latin typeface="Arial"/>
               </a:rPr>
-              <a:t>Fixes: three trade-offs; accept one and it re-runs in seconds</a:t>
+              <a:t>Labels say “not validated” or “no model yet” where the evidence is thin</a:t>
             </a:r>
           </a:p>
         </p:txBody>
@@ -9391,7 +9391,7 @@
                 </a:solidFill>
                 <a:latin typeface="Arial"/>
               </a:rPr>
-              <a:t>One screen shows the funnel, the risk and three fixes</a:t>
+              <a:t>The app shows where enrollment stalls and how likely trouble is, in plain words</a:t>
             </a:r>
           </a:p>
         </p:txBody>
@@ -9471,7 +9471,7 @@
                 </a:solidFill>
                 <a:latin typeface="Arial"/>
               </a:rPr>
-              <a:t>Sources: docs/screens/03-results.png</a:t>
+              <a:t>Sources: docs/screens/03-funnel-risk.png</a:t>
             </a:r>
           </a:p>
         </p:txBody>

</xml_diff>

<commit_message>
docs: state Gemini API use plainly; demo replays recorded Gemini outputs
Replace 'no API key needed' wording in README, ARCHITECTURE, VALIDATION,
Devpost text, video script and the deck (slides 8 and 12, notes, PDF and
renders). Text only; no code changed.

Co-Authored-By: Claude Opus 5.5 <noreply@anthropic.com>
</commit_message>
<xml_diff>
--- a/docs/deck/clinova.pptx
+++ b/docs/deck/clinova.pptx
@@ -723,7 +723,7 @@
           <a:lstStyle/>
           <a:p>
             <a:r>
-              <a:t>Next steps: expand beyond NSCLC to lymphoma, ophthalmology and immunology; simulate enrollment site by site; tune the persona model on expert feedback; accept structured protocols in ICH M11 format; and build a full GxP validation package. Everything is open source under MIT at https://github.com/RaghulKS/Clinova. One docker compose command starts the database, API and app, and demo mode runs on cached AI outputs with no keys. Roadmap: docs/ARCHITECTURE.md section 12.</a:t>
+              <a:t>Next steps: expand beyond NSCLC to lymphoma, ophthalmology and immunology; simulate enrollment site by site; tune the persona model on expert feedback; accept structured protocols in ICH M11 format; and build a full GxP validation package. Everything is open source under MIT at https://github.com/RaghulKS/Clinova. One docker compose command starts the database, API and app, and demo mode replays the Gemini API outputs recorded during the build. Roadmap: docs/ARCHITECTURE.md section 12.</a:t>
             </a:r>
           </a:p>
         </p:txBody>
@@ -1213,7 +1213,7 @@
           <a:lstStyle/>
           <a:p>
             <a:r>
-              <a:t>ClinicalTrials.gov records and their version history are ingested and labelled into Tiger Data, which is Postgres with TimescaleDB and pgvector. Gemini parses criteria; a code screen and persona agents simulate the cohort; LightGBM with SHAP scores risk; the optimizer re-scores every candidate edit in milliseconds; the learning loop logs and grades every prediction. Judges run it with one Docker Compose command and cached AI outputs. Four AI orchestrators across two model families ran 27 task prompts (count of orchestration/tasks/*.md).</a:t>
+              <a:t>ClinicalTrials.gov records and their version history are ingested and labelled into Tiger Data, which is Postgres with TimescaleDB and pgvector. Gemini parses criteria; a code screen and persona agents simulate the cohort; LightGBM with SHAP scores risk; the optimizer re-scores every candidate edit in milliseconds; the learning loop logs and grades every prediction. Judges run it with one Docker Compose command, replaying the Gemini outputs recorded during the build. Four AI orchestrators across two model families ran 27 task prompts (count of orchestration/tasks/*.md).</a:t>
             </a:r>
           </a:p>
         </p:txBody>
@@ -6121,7 +6121,7 @@
                 </a:solidFill>
                 <a:latin typeface="Arial"/>
               </a:rPr>
-              <a:t>MIT license. docker compose up, then open the app; demo mode needs no API keys.</a:t>
+              <a:t>MIT license. docker compose up, then open the app; demo mode replays recorded Gemini API outputs.</a:t>
             </a:r>
           </a:p>
         </p:txBody>

</xml_diff>